<commit_message>
Professor se terugvoer: Engels-only + empiriese regverdigings + kolom-motivasie
- scrape.py: language='all' → 'english' (VADER/TF-IDF werk slegs op Engels)
- clean.py: process_reviews() filter na Engels na overlay
- Fase2_Projek.ipynb:
  * Hoekom 50 bladsye = ~1 jaar (datumreeks per hoofgrootte)
  * Empiriese parameter-regverdiging (10-karakter, 50% ratio)
  * Kolom-motivasie-tabel (elke kolom → navorsingsvraag)
  * Skoonmaak-trechter-visualisering
  * Volledige Fase 2 Uitkoms-opsomming
</commit_message>
<xml_diff>
--- a/reports/Fase2_Aanbieding.pptx
+++ b/reports/Fase2_Aanbieding.pptx
@@ -4,21 +4,24 @@
   <p:sldMasterIdLst>
     <p:sldMasterId id="2147483648" r:id="rId1"/>
   </p:sldMasterIdLst>
+  <p:notesMasterIdLst>
+    <p:notesMasterId r:id="rId14"/>
+  </p:notesMasterIdLst>
   <p:sldIdLst>
-    <p:sldId id="256" r:id="rId7"/>
-    <p:sldId id="257" r:id="rId9"/>
-    <p:sldId id="258" r:id="rId10"/>
-    <p:sldId id="259" r:id="rId11"/>
-    <p:sldId id="260" r:id="rId12"/>
-    <p:sldId id="261" r:id="rId13"/>
-    <p:sldId id="262" r:id="rId14"/>
-    <p:sldId id="263" r:id="rId15"/>
-    <p:sldId id="264" r:id="rId16"/>
-    <p:sldId id="265" r:id="rId17"/>
-    <p:sldId id="266" r:id="rId18"/>
-    <p:sldId id="267" r:id="rId19"/>
+    <p:sldId id="256" r:id="rId2"/>
+    <p:sldId id="257" r:id="rId3"/>
+    <p:sldId id="258" r:id="rId4"/>
+    <p:sldId id="259" r:id="rId5"/>
+    <p:sldId id="260" r:id="rId6"/>
+    <p:sldId id="261" r:id="rId7"/>
+    <p:sldId id="262" r:id="rId8"/>
+    <p:sldId id="263" r:id="rId9"/>
+    <p:sldId id="264" r:id="rId10"/>
+    <p:sldId id="265" r:id="rId11"/>
+    <p:sldId id="266" r:id="rId12"/>
+    <p:sldId id="267" r:id="rId13"/>
   </p:sldIdLst>
-  <p:sldSz cx="12191695" cy="6858000" type="screen4x3"/>
+  <p:sldSz cx="12192000" cy="6858000"/>
   <p:notesSz cx="6858000" cy="9144000"/>
   <p:defaultTextStyle>
     <a:defPPr>
@@ -115,11 +118,27 @@
       </a:defRPr>
     </a:lvl9pPr>
   </p:defaultTextStyle>
+  <p:extLst>
+    <p:ext uri="{EFAFB233-063F-42B5-8137-9DF3F51BA10A}">
+      <p15:sldGuideLst xmlns:p15="http://schemas.microsoft.com/office/powerpoint/2012/main">
+        <p15:guide id="1" orient="horz" pos="2160">
+          <p15:clr>
+            <a:srgbClr val="A4A3A4"/>
+          </p15:clr>
+        </p15:guide>
+        <p15:guide id="2" pos="2880">
+          <p15:clr>
+            <a:srgbClr val="A4A3A4"/>
+          </p15:clr>
+        </p15:guide>
+      </p15:sldGuideLst>
+    </p:ext>
+  </p:extLst>
 </p:presentation>
 </file>
 
 <file path=ppt/notesMasters/notesMaster1.xml><?xml version="1.0" encoding="utf-8"?>
-<p:notesMaster xmlns:a="http://schemas.openxmlformats.org/drawingml/2006/main" xmlns:p="http://schemas.openxmlformats.org/presentationml/2006/main" xmlns:r="http://schemas.openxmlformats.org/officeDocument/2006/relationships">
+<p:notesMaster xmlns:a="http://schemas.openxmlformats.org/drawingml/2006/main" xmlns:r="http://schemas.openxmlformats.org/officeDocument/2006/relationships" xmlns:p="http://schemas.openxmlformats.org/presentationml/2006/main">
   <p:cSld>
     <p:bg>
       <p:bgRef idx="1001">
@@ -140,241 +159,16 @@
           <a:chExt cx="0" cy="0"/>
         </a:xfrm>
       </p:grpSpPr>
-      <p:sp>
-        <p:nvSpPr>
-          <p:cNvPr id="2" name="Header Placeholder 1"/>
-          <p:cNvSpPr>
-            <a:spLocks noGrp="1"/>
-          </p:cNvSpPr>
-          <p:nvPr>
-            <p:ph type="hdr" sz="quarter"/>
-          </p:nvPr>
-        </p:nvSpPr>
-        <p:spPr>
-          <a:xfrm>
-            <a:off x="0" y="0"/>
-            <a:ext cx="2971800" cy="457200"/>
-          </a:xfrm>
-          <a:prstGeom prst="rect">
-            <a:avLst/>
-          </a:prstGeom>
-        </p:spPr>
-        <p:txBody>
-          <a:bodyPr vert="horz" lIns="91440" tIns="45720" rIns="91440" bIns="45720" rtlCol="0"/>
-          <a:lstStyle>
-            <a:lvl1pPr algn="l">
-              <a:defRPr sz="1200"/>
-            </a:lvl1pPr>
-          </a:lstStyle>
-          <a:p>
-            <a:endParaRPr lang="en-US"/>
-          </a:p>
-        </p:txBody>
-      </p:sp>
-      <p:sp>
-        <p:nvSpPr>
-          <p:cNvPr id="3" name="Date Placeholder 2"/>
-          <p:cNvSpPr>
-            <a:spLocks noGrp="1"/>
-          </p:cNvSpPr>
-          <p:nvPr>
-            <p:ph type="dt" idx="1"/>
-          </p:nvPr>
-        </p:nvSpPr>
-        <p:spPr>
-          <a:xfrm>
-            <a:off x="3884613" y="0"/>
-            <a:ext cx="2971800" cy="457200"/>
-          </a:xfrm>
-          <a:prstGeom prst="rect">
-            <a:avLst/>
-          </a:prstGeom>
-        </p:spPr>
-        <p:txBody>
-          <a:bodyPr vert="horz" lIns="91440" tIns="45720" rIns="91440" bIns="45720" rtlCol="0"/>
-          <a:lstStyle>
-            <a:lvl1pPr algn="r">
-              <a:defRPr sz="1200"/>
-            </a:lvl1pPr>
-          </a:lstStyle>
-          <a:p>
-            <a:fld id="{0F89C1C7-3DCD-1040-A9CF-14679D8B5DDD}" type="datetimeFigureOut">
-              <a:rPr lang="en-US" smtClean="0"/>
-              <a:t>10/17/16</a:t>
-            </a:fld>
-            <a:endParaRPr lang="en-US"/>
-          </a:p>
-        </p:txBody>
-      </p:sp>
-      <p:sp>
-        <p:nvSpPr>
-          <p:cNvPr id="4" name="Slide Image Placeholder 3"/>
-          <p:cNvSpPr>
-            <a:spLocks noGrp="1" noRot="1" noChangeAspect="1"/>
-          </p:cNvSpPr>
-          <p:nvPr>
-            <p:ph type="sldImg" idx="2"/>
-          </p:nvPr>
-        </p:nvSpPr>
-        <p:spPr>
-          <a:xfrm>
-            <a:off x="1143000" y="685800"/>
-            <a:ext cx="4572000" cy="3429000"/>
-          </a:xfrm>
-          <a:prstGeom prst="rect">
-            <a:avLst/>
-          </a:prstGeom>
-          <a:noFill/>
-          <a:ln w="12700">
-            <a:solidFill>
-              <a:prstClr val="black"/>
-            </a:solidFill>
-          </a:ln>
-        </p:spPr>
-        <p:txBody>
-          <a:bodyPr vert="horz" lIns="91440" tIns="45720" rIns="91440" bIns="45720" rtlCol="0" anchor="ctr"/>
-          <a:lstStyle/>
-          <a:p>
-            <a:endParaRPr lang="en-US"/>
-          </a:p>
-        </p:txBody>
-      </p:sp>
-      <p:sp>
-        <p:nvSpPr>
-          <p:cNvPr id="5" name="Notes Placeholder 4"/>
-          <p:cNvSpPr>
-            <a:spLocks noGrp="1"/>
-          </p:cNvSpPr>
-          <p:nvPr>
-            <p:ph type="body" sz="quarter" idx="3"/>
-          </p:nvPr>
-        </p:nvSpPr>
-        <p:spPr>
-          <a:xfrm>
-            <a:off x="685800" y="4343400"/>
-            <a:ext cx="5486400" cy="4114800"/>
-          </a:xfrm>
-          <a:prstGeom prst="rect">
-            <a:avLst/>
-          </a:prstGeom>
-        </p:spPr>
-        <p:txBody>
-          <a:bodyPr vert="horz" lIns="91440" tIns="45720" rIns="91440" bIns="45720" rtlCol="0"/>
-          <a:lstStyle/>
-          <a:p>
-            <a:pPr lvl="0"/>
-            <a:r>
-              <a:rPr lang="en-US" smtClean="0"/>
-              <a:t>Click to edit Master text styles</a:t>
-            </a:r>
-          </a:p>
-          <a:p>
-            <a:pPr lvl="1"/>
-            <a:r>
-              <a:rPr lang="en-US" smtClean="0"/>
-              <a:t>Second level</a:t>
-            </a:r>
-          </a:p>
-          <a:p>
-            <a:pPr lvl="2"/>
-            <a:r>
-              <a:rPr lang="en-US" smtClean="0"/>
-              <a:t>Third level</a:t>
-            </a:r>
-          </a:p>
-          <a:p>
-            <a:pPr lvl="3"/>
-            <a:r>
-              <a:rPr lang="en-US" smtClean="0"/>
-              <a:t>Fourth level</a:t>
-            </a:r>
-          </a:p>
-          <a:p>
-            <a:pPr lvl="4"/>
-            <a:r>
-              <a:rPr lang="en-US" smtClean="0"/>
-              <a:t>Fifth level</a:t>
-            </a:r>
-            <a:endParaRPr lang="en-US"/>
-          </a:p>
-        </p:txBody>
-      </p:sp>
-      <p:sp>
-        <p:nvSpPr>
-          <p:cNvPr id="6" name="Footer Placeholder 5"/>
-          <p:cNvSpPr>
-            <a:spLocks noGrp="1"/>
-          </p:cNvSpPr>
-          <p:nvPr>
-            <p:ph type="ftr" sz="quarter" idx="4"/>
-          </p:nvPr>
-        </p:nvSpPr>
-        <p:spPr>
-          <a:xfrm>
-            <a:off x="0" y="8685213"/>
-            <a:ext cx="2971800" cy="457200"/>
-          </a:xfrm>
-          <a:prstGeom prst="rect">
-            <a:avLst/>
-          </a:prstGeom>
-        </p:spPr>
-        <p:txBody>
-          <a:bodyPr vert="horz" lIns="91440" tIns="45720" rIns="91440" bIns="45720" rtlCol="0" anchor="b"/>
-          <a:lstStyle>
-            <a:lvl1pPr algn="l">
-              <a:defRPr sz="1200"/>
-            </a:lvl1pPr>
-          </a:lstStyle>
-          <a:p>
-            <a:endParaRPr lang="en-US"/>
-          </a:p>
-        </p:txBody>
-      </p:sp>
-      <p:sp>
-        <p:nvSpPr>
-          <p:cNvPr id="7" name="Slide Number Placeholder 6"/>
-          <p:cNvSpPr>
-            <a:spLocks noGrp="1"/>
-          </p:cNvSpPr>
-          <p:nvPr>
-            <p:ph type="sldNum" sz="quarter" idx="5"/>
-          </p:nvPr>
-        </p:nvSpPr>
-        <p:spPr>
-          <a:xfrm>
-            <a:off x="3884613" y="8685213"/>
-            <a:ext cx="2971800" cy="457200"/>
-          </a:xfrm>
-          <a:prstGeom prst="rect">
-            <a:avLst/>
-          </a:prstGeom>
-        </p:spPr>
-        <p:txBody>
-          <a:bodyPr vert="horz" lIns="91440" tIns="45720" rIns="91440" bIns="45720" rtlCol="0" anchor="b"/>
-          <a:lstStyle>
-            <a:lvl1pPr algn="r">
-              <a:defRPr sz="1200"/>
-            </a:lvl1pPr>
-          </a:lstStyle>
-          <a:p>
-            <a:fld id="{BB5E49A5-4136-284D-997B-48E1D791AD67}" type="slidenum">
-              <a:rPr lang="en-US" smtClean="0"/>
-              <a:t>‹#›</a:t>
-            </a:fld>
-            <a:endParaRPr lang="en-US"/>
-          </a:p>
-        </p:txBody>
-      </p:sp>
     </p:spTree>
     <p:extLst>
       <p:ext uri="{BB962C8B-B14F-4D97-AF65-F5344CB8AC3E}">
-        <p14:creationId xmlns:p14="http://schemas.microsoft.com/office/powerpoint/2010/main" val="2623252185"/>
+        <p14:creationId xmlns:p14="http://schemas.microsoft.com/office/powerpoint/2010/main" val="298611989"/>
       </p:ext>
     </p:extLst>
   </p:cSld>
   <p:clrMap bg1="lt1" tx1="dk1" bg2="lt2" tx2="dk2" accent1="accent1" accent2="accent2" accent3="accent3" accent4="accent4" accent5="accent5" accent6="accent6" hlink="hlink" folHlink="folHlink"/>
   <p:notesStyle>
-    <a:lvl1pPr marL="0" algn="l" defTabSz="457200" rtl="0" eaLnBrk="1" latinLnBrk="0" hangingPunct="1">
+    <a:lvl1pPr marL="0" algn="l" defTabSz="914400" rtl="0" eaLnBrk="1" latinLnBrk="0" hangingPunct="1">
       <a:defRPr sz="1200" kern="1200">
         <a:solidFill>
           <a:schemeClr val="tx1"/>
@@ -384,7 +178,7 @@
         <a:cs typeface="+mn-cs"/>
       </a:defRPr>
     </a:lvl1pPr>
-    <a:lvl2pPr marL="457200" algn="l" defTabSz="457200" rtl="0" eaLnBrk="1" latinLnBrk="0" hangingPunct="1">
+    <a:lvl2pPr marL="457200" algn="l" defTabSz="914400" rtl="0" eaLnBrk="1" latinLnBrk="0" hangingPunct="1">
       <a:defRPr sz="1200" kern="1200">
         <a:solidFill>
           <a:schemeClr val="tx1"/>
@@ -394,7 +188,7 @@
         <a:cs typeface="+mn-cs"/>
       </a:defRPr>
     </a:lvl2pPr>
-    <a:lvl3pPr marL="914400" algn="l" defTabSz="457200" rtl="0" eaLnBrk="1" latinLnBrk="0" hangingPunct="1">
+    <a:lvl3pPr marL="914400" algn="l" defTabSz="914400" rtl="0" eaLnBrk="1" latinLnBrk="0" hangingPunct="1">
       <a:defRPr sz="1200" kern="1200">
         <a:solidFill>
           <a:schemeClr val="tx1"/>
@@ -404,7 +198,7 @@
         <a:cs typeface="+mn-cs"/>
       </a:defRPr>
     </a:lvl3pPr>
-    <a:lvl4pPr marL="1371600" algn="l" defTabSz="457200" rtl="0" eaLnBrk="1" latinLnBrk="0" hangingPunct="1">
+    <a:lvl4pPr marL="1371600" algn="l" defTabSz="914400" rtl="0" eaLnBrk="1" latinLnBrk="0" hangingPunct="1">
       <a:defRPr sz="1200" kern="1200">
         <a:solidFill>
           <a:schemeClr val="tx1"/>
@@ -414,7 +208,7 @@
         <a:cs typeface="+mn-cs"/>
       </a:defRPr>
     </a:lvl4pPr>
-    <a:lvl5pPr marL="1828800" algn="l" defTabSz="457200" rtl="0" eaLnBrk="1" latinLnBrk="0" hangingPunct="1">
+    <a:lvl5pPr marL="1828800" algn="l" defTabSz="914400" rtl="0" eaLnBrk="1" latinLnBrk="0" hangingPunct="1">
       <a:defRPr sz="1200" kern="1200">
         <a:solidFill>
           <a:schemeClr val="tx1"/>
@@ -424,7 +218,7 @@
         <a:cs typeface="+mn-cs"/>
       </a:defRPr>
     </a:lvl5pPr>
-    <a:lvl6pPr marL="2286000" algn="l" defTabSz="457200" rtl="0" eaLnBrk="1" latinLnBrk="0" hangingPunct="1">
+    <a:lvl6pPr marL="2286000" algn="l" defTabSz="914400" rtl="0" eaLnBrk="1" latinLnBrk="0" hangingPunct="1">
       <a:defRPr sz="1200" kern="1200">
         <a:solidFill>
           <a:schemeClr val="tx1"/>
@@ -434,7 +228,7 @@
         <a:cs typeface="+mn-cs"/>
       </a:defRPr>
     </a:lvl6pPr>
-    <a:lvl7pPr marL="2743200" algn="l" defTabSz="457200" rtl="0" eaLnBrk="1" latinLnBrk="0" hangingPunct="1">
+    <a:lvl7pPr marL="2743200" algn="l" defTabSz="914400" rtl="0" eaLnBrk="1" latinLnBrk="0" hangingPunct="1">
       <a:defRPr sz="1200" kern="1200">
         <a:solidFill>
           <a:schemeClr val="tx1"/>
@@ -444,7 +238,7 @@
         <a:cs typeface="+mn-cs"/>
       </a:defRPr>
     </a:lvl7pPr>
-    <a:lvl8pPr marL="3200400" algn="l" defTabSz="457200" rtl="0" eaLnBrk="1" latinLnBrk="0" hangingPunct="1">
+    <a:lvl8pPr marL="3200400" algn="l" defTabSz="914400" rtl="0" eaLnBrk="1" latinLnBrk="0" hangingPunct="1">
       <a:defRPr sz="1200" kern="1200">
         <a:solidFill>
           <a:schemeClr val="tx1"/>
@@ -454,7 +248,7 @@
         <a:cs typeface="+mn-cs"/>
       </a:defRPr>
     </a:lvl8pPr>
-    <a:lvl9pPr marL="3657600" algn="l" defTabSz="457200" rtl="0" eaLnBrk="1" latinLnBrk="0" hangingPunct="1">
+    <a:lvl9pPr marL="3657600" algn="l" defTabSz="914400" rtl="0" eaLnBrk="1" latinLnBrk="0" hangingPunct="1">
       <a:defRPr sz="1200" kern="1200">
         <a:solidFill>
           <a:schemeClr val="tx1"/>
@@ -469,7 +263,7 @@
 </file>
 
 <file path=ppt/notesSlides/notesSlide1.xml><?xml version="1.0" encoding="utf-8"?>
-<p:notes xmlns:a="http://schemas.openxmlformats.org/drawingml/2006/main" xmlns:p="http://schemas.openxmlformats.org/presentationml/2006/main" xmlns:r="http://schemas.openxmlformats.org/officeDocument/2006/relationships">
+<p:notes xmlns:a="http://schemas.openxmlformats.org/drawingml/2006/main" xmlns:r="http://schemas.openxmlformats.org/officeDocument/2006/relationships" xmlns:p="http://schemas.openxmlformats.org/presentationml/2006/main">
   <p:cSld>
     <p:spTree>
       <p:nvGrpSpPr>
@@ -489,7 +283,7 @@
         <p:nvSpPr>
           <p:cNvPr id="2" name="Slide Image Placeholder 1"/>
           <p:cNvSpPr>
-            <a:spLocks noGrp="1"/>
+            <a:spLocks noGrp="1" noRot="1" noChangeAspect="1"/>
           </p:cNvSpPr>
           <p:nvPr>
             <p:ph type="sldImg" idx="2"/>
@@ -504,7 +298,7 @@
             <a:spLocks noGrp="1"/>
           </p:cNvSpPr>
           <p:nvPr>
-            <p:ph type="body" idx="3" sz="quarter"/>
+            <p:ph type="body" sz="quarter" idx="3"/>
           </p:nvPr>
         </p:nvSpPr>
         <p:spPr/>
@@ -530,7 +324,7 @@
             <a:spLocks noGrp="1"/>
           </p:cNvSpPr>
           <p:nvPr>
-            <p:ph type="sldNum" idx="5" sz="quarter"/>
+            <p:ph type="sldNum" sz="quarter" idx="5"/>
           </p:nvPr>
         </p:nvSpPr>
         <p:spPr/>
@@ -544,7 +338,7 @@
 </file>
 
 <file path=ppt/notesSlides/notesSlide10.xml><?xml version="1.0" encoding="utf-8"?>
-<p:notes xmlns:a="http://schemas.openxmlformats.org/drawingml/2006/main" xmlns:p="http://schemas.openxmlformats.org/presentationml/2006/main" xmlns:r="http://schemas.openxmlformats.org/officeDocument/2006/relationships">
+<p:notes xmlns:a="http://schemas.openxmlformats.org/drawingml/2006/main" xmlns:r="http://schemas.openxmlformats.org/officeDocument/2006/relationships" xmlns:p="http://schemas.openxmlformats.org/presentationml/2006/main">
   <p:cSld>
     <p:spTree>
       <p:nvGrpSpPr>
@@ -564,7 +358,7 @@
         <p:nvSpPr>
           <p:cNvPr id="2" name="Slide Image Placeholder 1"/>
           <p:cNvSpPr>
-            <a:spLocks noGrp="1"/>
+            <a:spLocks noGrp="1" noRot="1" noChangeAspect="1"/>
           </p:cNvSpPr>
           <p:nvPr>
             <p:ph type="sldImg" idx="2"/>
@@ -579,7 +373,7 @@
             <a:spLocks noGrp="1"/>
           </p:cNvSpPr>
           <p:nvPr>
-            <p:ph type="body" idx="3" sz="quarter"/>
+            <p:ph type="body" sz="quarter" idx="3"/>
           </p:nvPr>
         </p:nvSpPr>
         <p:spPr/>
@@ -605,7 +399,7 @@
             <a:spLocks noGrp="1"/>
           </p:cNvSpPr>
           <p:nvPr>
-            <p:ph type="sldNum" idx="5" sz="quarter"/>
+            <p:ph type="sldNum" sz="quarter" idx="5"/>
           </p:nvPr>
         </p:nvSpPr>
         <p:spPr/>
@@ -619,7 +413,7 @@
 </file>
 
 <file path=ppt/notesSlides/notesSlide11.xml><?xml version="1.0" encoding="utf-8"?>
-<p:notes xmlns:a="http://schemas.openxmlformats.org/drawingml/2006/main" xmlns:p="http://schemas.openxmlformats.org/presentationml/2006/main" xmlns:r="http://schemas.openxmlformats.org/officeDocument/2006/relationships">
+<p:notes xmlns:a="http://schemas.openxmlformats.org/drawingml/2006/main" xmlns:r="http://schemas.openxmlformats.org/officeDocument/2006/relationships" xmlns:p="http://schemas.openxmlformats.org/presentationml/2006/main">
   <p:cSld>
     <p:spTree>
       <p:nvGrpSpPr>
@@ -639,7 +433,7 @@
         <p:nvSpPr>
           <p:cNvPr id="2" name="Slide Image Placeholder 1"/>
           <p:cNvSpPr>
-            <a:spLocks noGrp="1"/>
+            <a:spLocks noGrp="1" noRot="1" noChangeAspect="1"/>
           </p:cNvSpPr>
           <p:nvPr>
             <p:ph type="sldImg" idx="2"/>
@@ -654,7 +448,7 @@
             <a:spLocks noGrp="1"/>
           </p:cNvSpPr>
           <p:nvPr>
-            <p:ph type="body" idx="3" sz="quarter"/>
+            <p:ph type="body" sz="quarter" idx="3"/>
           </p:nvPr>
         </p:nvSpPr>
         <p:spPr/>
@@ -675,7 +469,7 @@
             <a:spLocks noGrp="1"/>
           </p:cNvSpPr>
           <p:nvPr>
-            <p:ph type="sldNum" idx="5" sz="quarter"/>
+            <p:ph type="sldNum" sz="quarter" idx="5"/>
           </p:nvPr>
         </p:nvSpPr>
         <p:spPr/>
@@ -689,7 +483,7 @@
 </file>
 
 <file path=ppt/notesSlides/notesSlide12.xml><?xml version="1.0" encoding="utf-8"?>
-<p:notes xmlns:a="http://schemas.openxmlformats.org/drawingml/2006/main" xmlns:p="http://schemas.openxmlformats.org/presentationml/2006/main" xmlns:r="http://schemas.openxmlformats.org/officeDocument/2006/relationships">
+<p:notes xmlns:a="http://schemas.openxmlformats.org/drawingml/2006/main" xmlns:r="http://schemas.openxmlformats.org/officeDocument/2006/relationships" xmlns:p="http://schemas.openxmlformats.org/presentationml/2006/main">
   <p:cSld>
     <p:spTree>
       <p:nvGrpSpPr>
@@ -709,7 +503,7 @@
         <p:nvSpPr>
           <p:cNvPr id="2" name="Slide Image Placeholder 1"/>
           <p:cNvSpPr>
-            <a:spLocks noGrp="1"/>
+            <a:spLocks noGrp="1" noRot="1" noChangeAspect="1"/>
           </p:cNvSpPr>
           <p:nvPr>
             <p:ph type="sldImg" idx="2"/>
@@ -724,7 +518,7 @@
             <a:spLocks noGrp="1"/>
           </p:cNvSpPr>
           <p:nvPr>
-            <p:ph type="body" idx="3" sz="quarter"/>
+            <p:ph type="body" sz="quarter" idx="3"/>
           </p:nvPr>
         </p:nvSpPr>
         <p:spPr/>
@@ -750,7 +544,7 @@
             <a:spLocks noGrp="1"/>
           </p:cNvSpPr>
           <p:nvPr>
-            <p:ph type="sldNum" idx="5" sz="quarter"/>
+            <p:ph type="sldNum" sz="quarter" idx="5"/>
           </p:nvPr>
         </p:nvSpPr>
         <p:spPr/>
@@ -764,7 +558,7 @@
 </file>
 
 <file path=ppt/notesSlides/notesSlide2.xml><?xml version="1.0" encoding="utf-8"?>
-<p:notes xmlns:a="http://schemas.openxmlformats.org/drawingml/2006/main" xmlns:p="http://schemas.openxmlformats.org/presentationml/2006/main" xmlns:r="http://schemas.openxmlformats.org/officeDocument/2006/relationships">
+<p:notes xmlns:a="http://schemas.openxmlformats.org/drawingml/2006/main" xmlns:r="http://schemas.openxmlformats.org/officeDocument/2006/relationships" xmlns:p="http://schemas.openxmlformats.org/presentationml/2006/main">
   <p:cSld>
     <p:spTree>
       <p:nvGrpSpPr>
@@ -784,7 +578,7 @@
         <p:nvSpPr>
           <p:cNvPr id="2" name="Slide Image Placeholder 1"/>
           <p:cNvSpPr>
-            <a:spLocks noGrp="1"/>
+            <a:spLocks noGrp="1" noRot="1" noChangeAspect="1"/>
           </p:cNvSpPr>
           <p:nvPr>
             <p:ph type="sldImg" idx="2"/>
@@ -799,7 +593,7 @@
             <a:spLocks noGrp="1"/>
           </p:cNvSpPr>
           <p:nvPr>
-            <p:ph type="body" idx="3" sz="quarter"/>
+            <p:ph type="body" sz="quarter" idx="3"/>
           </p:nvPr>
         </p:nvSpPr>
         <p:spPr/>
@@ -825,7 +619,7 @@
             <a:spLocks noGrp="1"/>
           </p:cNvSpPr>
           <p:nvPr>
-            <p:ph type="sldNum" idx="5" sz="quarter"/>
+            <p:ph type="sldNum" sz="quarter" idx="5"/>
           </p:nvPr>
         </p:nvSpPr>
         <p:spPr/>
@@ -839,7 +633,7 @@
 </file>
 
 <file path=ppt/notesSlides/notesSlide3.xml><?xml version="1.0" encoding="utf-8"?>
-<p:notes xmlns:a="http://schemas.openxmlformats.org/drawingml/2006/main" xmlns:p="http://schemas.openxmlformats.org/presentationml/2006/main" xmlns:r="http://schemas.openxmlformats.org/officeDocument/2006/relationships">
+<p:notes xmlns:a="http://schemas.openxmlformats.org/drawingml/2006/main" xmlns:r="http://schemas.openxmlformats.org/officeDocument/2006/relationships" xmlns:p="http://schemas.openxmlformats.org/presentationml/2006/main">
   <p:cSld>
     <p:spTree>
       <p:nvGrpSpPr>
@@ -859,7 +653,7 @@
         <p:nvSpPr>
           <p:cNvPr id="2" name="Slide Image Placeholder 1"/>
           <p:cNvSpPr>
-            <a:spLocks noGrp="1"/>
+            <a:spLocks noGrp="1" noRot="1" noChangeAspect="1"/>
           </p:cNvSpPr>
           <p:nvPr>
             <p:ph type="sldImg" idx="2"/>
@@ -874,7 +668,7 @@
             <a:spLocks noGrp="1"/>
           </p:cNvSpPr>
           <p:nvPr>
-            <p:ph type="body" idx="3" sz="quarter"/>
+            <p:ph type="body" sz="quarter" idx="3"/>
           </p:nvPr>
         </p:nvSpPr>
         <p:spPr/>
@@ -900,7 +694,7 @@
             <a:spLocks noGrp="1"/>
           </p:cNvSpPr>
           <p:nvPr>
-            <p:ph type="sldNum" idx="5" sz="quarter"/>
+            <p:ph type="sldNum" sz="quarter" idx="5"/>
           </p:nvPr>
         </p:nvSpPr>
         <p:spPr/>
@@ -914,7 +708,7 @@
 </file>
 
 <file path=ppt/notesSlides/notesSlide4.xml><?xml version="1.0" encoding="utf-8"?>
-<p:notes xmlns:a="http://schemas.openxmlformats.org/drawingml/2006/main" xmlns:p="http://schemas.openxmlformats.org/presentationml/2006/main" xmlns:r="http://schemas.openxmlformats.org/officeDocument/2006/relationships">
+<p:notes xmlns:a="http://schemas.openxmlformats.org/drawingml/2006/main" xmlns:r="http://schemas.openxmlformats.org/officeDocument/2006/relationships" xmlns:p="http://schemas.openxmlformats.org/presentationml/2006/main">
   <p:cSld>
     <p:spTree>
       <p:nvGrpSpPr>
@@ -934,7 +728,7 @@
         <p:nvSpPr>
           <p:cNvPr id="2" name="Slide Image Placeholder 1"/>
           <p:cNvSpPr>
-            <a:spLocks noGrp="1"/>
+            <a:spLocks noGrp="1" noRot="1" noChangeAspect="1"/>
           </p:cNvSpPr>
           <p:nvPr>
             <p:ph type="sldImg" idx="2"/>
@@ -949,7 +743,7 @@
             <a:spLocks noGrp="1"/>
           </p:cNvSpPr>
           <p:nvPr>
-            <p:ph type="body" idx="3" sz="quarter"/>
+            <p:ph type="body" sz="quarter" idx="3"/>
           </p:nvPr>
         </p:nvSpPr>
         <p:spPr/>
@@ -975,7 +769,7 @@
             <a:spLocks noGrp="1"/>
           </p:cNvSpPr>
           <p:nvPr>
-            <p:ph type="sldNum" idx="5" sz="quarter"/>
+            <p:ph type="sldNum" sz="quarter" idx="5"/>
           </p:nvPr>
         </p:nvSpPr>
         <p:spPr/>
@@ -989,7 +783,7 @@
 </file>
 
 <file path=ppt/notesSlides/notesSlide5.xml><?xml version="1.0" encoding="utf-8"?>
-<p:notes xmlns:a="http://schemas.openxmlformats.org/drawingml/2006/main" xmlns:p="http://schemas.openxmlformats.org/presentationml/2006/main" xmlns:r="http://schemas.openxmlformats.org/officeDocument/2006/relationships">
+<p:notes xmlns:a="http://schemas.openxmlformats.org/drawingml/2006/main" xmlns:r="http://schemas.openxmlformats.org/officeDocument/2006/relationships" xmlns:p="http://schemas.openxmlformats.org/presentationml/2006/main">
   <p:cSld>
     <p:spTree>
       <p:nvGrpSpPr>
@@ -1009,7 +803,7 @@
         <p:nvSpPr>
           <p:cNvPr id="2" name="Slide Image Placeholder 1"/>
           <p:cNvSpPr>
-            <a:spLocks noGrp="1"/>
+            <a:spLocks noGrp="1" noRot="1" noChangeAspect="1"/>
           </p:cNvSpPr>
           <p:nvPr>
             <p:ph type="sldImg" idx="2"/>
@@ -1024,7 +818,7 @@
             <a:spLocks noGrp="1"/>
           </p:cNvSpPr>
           <p:nvPr>
-            <p:ph type="body" idx="3" sz="quarter"/>
+            <p:ph type="body" sz="quarter" idx="3"/>
           </p:nvPr>
         </p:nvSpPr>
         <p:spPr/>
@@ -1050,7 +844,7 @@
             <a:spLocks noGrp="1"/>
           </p:cNvSpPr>
           <p:nvPr>
-            <p:ph type="sldNum" idx="5" sz="quarter"/>
+            <p:ph type="sldNum" sz="quarter" idx="5"/>
           </p:nvPr>
         </p:nvSpPr>
         <p:spPr/>
@@ -1064,7 +858,7 @@
 </file>
 
 <file path=ppt/notesSlides/notesSlide6.xml><?xml version="1.0" encoding="utf-8"?>
-<p:notes xmlns:a="http://schemas.openxmlformats.org/drawingml/2006/main" xmlns:p="http://schemas.openxmlformats.org/presentationml/2006/main" xmlns:r="http://schemas.openxmlformats.org/officeDocument/2006/relationships">
+<p:notes xmlns:a="http://schemas.openxmlformats.org/drawingml/2006/main" xmlns:r="http://schemas.openxmlformats.org/officeDocument/2006/relationships" xmlns:p="http://schemas.openxmlformats.org/presentationml/2006/main">
   <p:cSld>
     <p:spTree>
       <p:nvGrpSpPr>
@@ -1084,7 +878,7 @@
         <p:nvSpPr>
           <p:cNvPr id="2" name="Slide Image Placeholder 1"/>
           <p:cNvSpPr>
-            <a:spLocks noGrp="1"/>
+            <a:spLocks noGrp="1" noRot="1" noChangeAspect="1"/>
           </p:cNvSpPr>
           <p:nvPr>
             <p:ph type="sldImg" idx="2"/>
@@ -1099,7 +893,7 @@
             <a:spLocks noGrp="1"/>
           </p:cNvSpPr>
           <p:nvPr>
-            <p:ph type="body" idx="3" sz="quarter"/>
+            <p:ph type="body" sz="quarter" idx="3"/>
           </p:nvPr>
         </p:nvSpPr>
         <p:spPr/>
@@ -1120,7 +914,7 @@
             <a:spLocks noGrp="1"/>
           </p:cNvSpPr>
           <p:nvPr>
-            <p:ph type="sldNum" idx="5" sz="quarter"/>
+            <p:ph type="sldNum" sz="quarter" idx="5"/>
           </p:nvPr>
         </p:nvSpPr>
         <p:spPr/>
@@ -1134,7 +928,7 @@
 </file>
 
 <file path=ppt/notesSlides/notesSlide7.xml><?xml version="1.0" encoding="utf-8"?>
-<p:notes xmlns:a="http://schemas.openxmlformats.org/drawingml/2006/main" xmlns:p="http://schemas.openxmlformats.org/presentationml/2006/main" xmlns:r="http://schemas.openxmlformats.org/officeDocument/2006/relationships">
+<p:notes xmlns:a="http://schemas.openxmlformats.org/drawingml/2006/main" xmlns:r="http://schemas.openxmlformats.org/officeDocument/2006/relationships" xmlns:p="http://schemas.openxmlformats.org/presentationml/2006/main">
   <p:cSld>
     <p:spTree>
       <p:nvGrpSpPr>
@@ -1154,7 +948,7 @@
         <p:nvSpPr>
           <p:cNvPr id="2" name="Slide Image Placeholder 1"/>
           <p:cNvSpPr>
-            <a:spLocks noGrp="1"/>
+            <a:spLocks noGrp="1" noRot="1" noChangeAspect="1"/>
           </p:cNvSpPr>
           <p:nvPr>
             <p:ph type="sldImg" idx="2"/>
@@ -1169,7 +963,7 @@
             <a:spLocks noGrp="1"/>
           </p:cNvSpPr>
           <p:nvPr>
-            <p:ph type="body" idx="3" sz="quarter"/>
+            <p:ph type="body" sz="quarter" idx="3"/>
           </p:nvPr>
         </p:nvSpPr>
         <p:spPr/>
@@ -1195,7 +989,7 @@
             <a:spLocks noGrp="1"/>
           </p:cNvSpPr>
           <p:nvPr>
-            <p:ph type="sldNum" idx="5" sz="quarter"/>
+            <p:ph type="sldNum" sz="quarter" idx="5"/>
           </p:nvPr>
         </p:nvSpPr>
         <p:spPr/>
@@ -1209,7 +1003,7 @@
 </file>
 
 <file path=ppt/notesSlides/notesSlide8.xml><?xml version="1.0" encoding="utf-8"?>
-<p:notes xmlns:a="http://schemas.openxmlformats.org/drawingml/2006/main" xmlns:p="http://schemas.openxmlformats.org/presentationml/2006/main" xmlns:r="http://schemas.openxmlformats.org/officeDocument/2006/relationships">
+<p:notes xmlns:a="http://schemas.openxmlformats.org/drawingml/2006/main" xmlns:r="http://schemas.openxmlformats.org/officeDocument/2006/relationships" xmlns:p="http://schemas.openxmlformats.org/presentationml/2006/main">
   <p:cSld>
     <p:spTree>
       <p:nvGrpSpPr>
@@ -1229,7 +1023,7 @@
         <p:nvSpPr>
           <p:cNvPr id="2" name="Slide Image Placeholder 1"/>
           <p:cNvSpPr>
-            <a:spLocks noGrp="1"/>
+            <a:spLocks noGrp="1" noRot="1" noChangeAspect="1"/>
           </p:cNvSpPr>
           <p:nvPr>
             <p:ph type="sldImg" idx="2"/>
@@ -1244,7 +1038,7 @@
             <a:spLocks noGrp="1"/>
           </p:cNvSpPr>
           <p:nvPr>
-            <p:ph type="body" idx="3" sz="quarter"/>
+            <p:ph type="body" sz="quarter" idx="3"/>
           </p:nvPr>
         </p:nvSpPr>
         <p:spPr/>
@@ -1270,7 +1064,7 @@
             <a:spLocks noGrp="1"/>
           </p:cNvSpPr>
           <p:nvPr>
-            <p:ph type="sldNum" idx="5" sz="quarter"/>
+            <p:ph type="sldNum" sz="quarter" idx="5"/>
           </p:nvPr>
         </p:nvSpPr>
         <p:spPr/>
@@ -1284,7 +1078,7 @@
 </file>
 
 <file path=ppt/notesSlides/notesSlide9.xml><?xml version="1.0" encoding="utf-8"?>
-<p:notes xmlns:a="http://schemas.openxmlformats.org/drawingml/2006/main" xmlns:p="http://schemas.openxmlformats.org/presentationml/2006/main" xmlns:r="http://schemas.openxmlformats.org/officeDocument/2006/relationships">
+<p:notes xmlns:a="http://schemas.openxmlformats.org/drawingml/2006/main" xmlns:r="http://schemas.openxmlformats.org/officeDocument/2006/relationships" xmlns:p="http://schemas.openxmlformats.org/presentationml/2006/main">
   <p:cSld>
     <p:spTree>
       <p:nvGrpSpPr>
@@ -1304,7 +1098,7 @@
         <p:nvSpPr>
           <p:cNvPr id="2" name="Slide Image Placeholder 1"/>
           <p:cNvSpPr>
-            <a:spLocks noGrp="1"/>
+            <a:spLocks noGrp="1" noRot="1" noChangeAspect="1"/>
           </p:cNvSpPr>
           <p:nvPr>
             <p:ph type="sldImg" idx="2"/>
@@ -1319,7 +1113,7 @@
             <a:spLocks noGrp="1"/>
           </p:cNvSpPr>
           <p:nvPr>
-            <p:ph type="body" idx="3" sz="quarter"/>
+            <p:ph type="body" sz="quarter" idx="3"/>
           </p:nvPr>
         </p:nvSpPr>
         <p:spPr/>
@@ -1345,7 +1139,7 @@
             <a:spLocks noGrp="1"/>
           </p:cNvSpPr>
           <p:nvPr>
-            <p:ph type="sldNum" idx="5" sz="quarter"/>
+            <p:ph type="sldNum" sz="quarter" idx="5"/>
           </p:nvPr>
         </p:nvSpPr>
         <p:spPr/>
@@ -1396,10 +1190,9 @@
           <a:lstStyle/>
           <a:p>
             <a:r>
-              <a:rPr lang="en-US" smtClean="0"/>
+              <a:rPr lang="en-US"/>
               <a:t>Click to edit Master title style</a:t>
             </a:r>
-            <a:endParaRPr lang="en-US"/>
           </a:p>
         </p:txBody>
       </p:sp>
@@ -1515,10 +1308,9 @@
           </a:lstStyle>
           <a:p>
             <a:r>
-              <a:rPr lang="en-US" smtClean="0"/>
+              <a:rPr lang="en-US"/>
               <a:t>Click to edit Master subtitle style</a:t>
             </a:r>
-            <a:endParaRPr lang="en-US"/>
           </a:p>
         </p:txBody>
       </p:sp>
@@ -1539,7 +1331,7 @@
           <a:p>
             <a:fld id="{5BCAD085-E8A6-8845-BD4E-CB4CCA059FC4}" type="datetimeFigureOut">
               <a:rPr lang="en-US" smtClean="0"/>
-              <a:t>1/27/13</a:t>
+              <a:t>8/13/2026</a:t>
             </a:fld>
             <a:endParaRPr lang="en-US"/>
           </a:p>
@@ -1633,10 +1425,9 @@
           <a:lstStyle/>
           <a:p>
             <a:r>
-              <a:rPr lang="en-US" smtClean="0"/>
+              <a:rPr lang="en-US"/>
               <a:t>Click to edit Master title style</a:t>
             </a:r>
-            <a:endParaRPr lang="en-US"/>
           </a:p>
         </p:txBody>
       </p:sp>
@@ -1657,38 +1448,37 @@
           <a:p>
             <a:pPr lvl="0"/>
             <a:r>
-              <a:rPr lang="en-US" smtClean="0"/>
+              <a:rPr lang="en-US"/>
               <a:t>Click to edit Master text styles</a:t>
             </a:r>
           </a:p>
           <a:p>
             <a:pPr lvl="1"/>
             <a:r>
-              <a:rPr lang="en-US" smtClean="0"/>
+              <a:rPr lang="en-US"/>
               <a:t>Second level</a:t>
             </a:r>
           </a:p>
           <a:p>
             <a:pPr lvl="2"/>
             <a:r>
-              <a:rPr lang="en-US" smtClean="0"/>
+              <a:rPr lang="en-US"/>
               <a:t>Third level</a:t>
             </a:r>
           </a:p>
           <a:p>
             <a:pPr lvl="3"/>
             <a:r>
-              <a:rPr lang="en-US" smtClean="0"/>
+              <a:rPr lang="en-US"/>
               <a:t>Fourth level</a:t>
             </a:r>
           </a:p>
           <a:p>
             <a:pPr lvl="4"/>
             <a:r>
-              <a:rPr lang="en-US" smtClean="0"/>
+              <a:rPr lang="en-US"/>
               <a:t>Fifth level</a:t>
             </a:r>
-            <a:endParaRPr lang="en-US"/>
           </a:p>
         </p:txBody>
       </p:sp>
@@ -1709,7 +1499,7 @@
           <a:p>
             <a:fld id="{5BCAD085-E8A6-8845-BD4E-CB4CCA059FC4}" type="datetimeFigureOut">
               <a:rPr lang="en-US" smtClean="0"/>
-              <a:t>1/27/13</a:t>
+              <a:t>8/13/2026</a:t>
             </a:fld>
             <a:endParaRPr lang="en-US"/>
           </a:p>
@@ -1808,10 +1598,9 @@
           <a:lstStyle/>
           <a:p>
             <a:r>
-              <a:rPr lang="en-US" smtClean="0"/>
+              <a:rPr lang="en-US"/>
               <a:t>Click to edit Master title style</a:t>
             </a:r>
-            <a:endParaRPr lang="en-US"/>
           </a:p>
         </p:txBody>
       </p:sp>
@@ -1837,38 +1626,37 @@
           <a:p>
             <a:pPr lvl="0"/>
             <a:r>
-              <a:rPr lang="en-US" smtClean="0"/>
+              <a:rPr lang="en-US"/>
               <a:t>Click to edit Master text styles</a:t>
             </a:r>
           </a:p>
           <a:p>
             <a:pPr lvl="1"/>
             <a:r>
-              <a:rPr lang="en-US" smtClean="0"/>
+              <a:rPr lang="en-US"/>
               <a:t>Second level</a:t>
             </a:r>
           </a:p>
           <a:p>
             <a:pPr lvl="2"/>
             <a:r>
-              <a:rPr lang="en-US" smtClean="0"/>
+              <a:rPr lang="en-US"/>
               <a:t>Third level</a:t>
             </a:r>
           </a:p>
           <a:p>
             <a:pPr lvl="3"/>
             <a:r>
-              <a:rPr lang="en-US" smtClean="0"/>
+              <a:rPr lang="en-US"/>
               <a:t>Fourth level</a:t>
             </a:r>
           </a:p>
           <a:p>
             <a:pPr lvl="4"/>
             <a:r>
-              <a:rPr lang="en-US" smtClean="0"/>
+              <a:rPr lang="en-US"/>
               <a:t>Fifth level</a:t>
             </a:r>
-            <a:endParaRPr lang="en-US"/>
           </a:p>
         </p:txBody>
       </p:sp>
@@ -1889,7 +1677,7 @@
           <a:p>
             <a:fld id="{5BCAD085-E8A6-8845-BD4E-CB4CCA059FC4}" type="datetimeFigureOut">
               <a:rPr lang="en-US" smtClean="0"/>
-              <a:t>1/27/13</a:t>
+              <a:t>8/13/2026</a:t>
             </a:fld>
             <a:endParaRPr lang="en-US"/>
           </a:p>
@@ -1983,10 +1771,9 @@
           <a:lstStyle/>
           <a:p>
             <a:r>
-              <a:rPr lang="en-US" smtClean="0"/>
+              <a:rPr lang="en-US"/>
               <a:t>Click to edit Master title style</a:t>
             </a:r>
-            <a:endParaRPr lang="en-US"/>
           </a:p>
         </p:txBody>
       </p:sp>
@@ -2007,38 +1794,37 @@
           <a:p>
             <a:pPr lvl="0"/>
             <a:r>
-              <a:rPr lang="en-US" smtClean="0"/>
+              <a:rPr lang="en-US"/>
               <a:t>Click to edit Master text styles</a:t>
             </a:r>
           </a:p>
           <a:p>
             <a:pPr lvl="1"/>
             <a:r>
-              <a:rPr lang="en-US" smtClean="0"/>
+              <a:rPr lang="en-US"/>
               <a:t>Second level</a:t>
             </a:r>
           </a:p>
           <a:p>
             <a:pPr lvl="2"/>
             <a:r>
-              <a:rPr lang="en-US" smtClean="0"/>
+              <a:rPr lang="en-US"/>
               <a:t>Third level</a:t>
             </a:r>
           </a:p>
           <a:p>
             <a:pPr lvl="3"/>
             <a:r>
-              <a:rPr lang="en-US" smtClean="0"/>
+              <a:rPr lang="en-US"/>
               <a:t>Fourth level</a:t>
             </a:r>
           </a:p>
           <a:p>
             <a:pPr lvl="4"/>
             <a:r>
-              <a:rPr lang="en-US" smtClean="0"/>
+              <a:rPr lang="en-US"/>
               <a:t>Fifth level</a:t>
             </a:r>
-            <a:endParaRPr lang="en-US"/>
           </a:p>
         </p:txBody>
       </p:sp>
@@ -2059,7 +1845,7 @@
           <a:p>
             <a:fld id="{5BCAD085-E8A6-8845-BD4E-CB4CCA059FC4}" type="datetimeFigureOut">
               <a:rPr lang="en-US" smtClean="0"/>
-              <a:t>1/27/13</a:t>
+              <a:t>8/13/2026</a:t>
             </a:fld>
             <a:endParaRPr lang="en-US"/>
           </a:p>
@@ -2162,10 +1948,9 @@
           </a:lstStyle>
           <a:p>
             <a:r>
-              <a:rPr lang="en-US" smtClean="0"/>
+              <a:rPr lang="en-US"/>
               <a:t>Click to edit Master title style</a:t>
             </a:r>
-            <a:endParaRPr lang="en-US"/>
           </a:p>
         </p:txBody>
       </p:sp>
@@ -2282,7 +2067,7 @@
           <a:p>
             <a:pPr lvl="0"/>
             <a:r>
-              <a:rPr lang="en-US" smtClean="0"/>
+              <a:rPr lang="en-US"/>
               <a:t>Click to edit Master text styles</a:t>
             </a:r>
           </a:p>
@@ -2305,7 +2090,7 @@
           <a:p>
             <a:fld id="{5BCAD085-E8A6-8845-BD4E-CB4CCA059FC4}" type="datetimeFigureOut">
               <a:rPr lang="en-US" smtClean="0"/>
-              <a:t>1/27/13</a:t>
+              <a:t>8/13/2026</a:t>
             </a:fld>
             <a:endParaRPr lang="en-US"/>
           </a:p>
@@ -2399,10 +2184,9 @@
           <a:lstStyle/>
           <a:p>
             <a:r>
-              <a:rPr lang="en-US" smtClean="0"/>
+              <a:rPr lang="en-US"/>
               <a:t>Click to edit Master title style</a:t>
             </a:r>
-            <a:endParaRPr lang="en-US"/>
           </a:p>
         </p:txBody>
       </p:sp>
@@ -2456,38 +2240,37 @@
           <a:p>
             <a:pPr lvl="0"/>
             <a:r>
-              <a:rPr lang="en-US" smtClean="0"/>
+              <a:rPr lang="en-US"/>
               <a:t>Click to edit Master text styles</a:t>
             </a:r>
           </a:p>
           <a:p>
             <a:pPr lvl="1"/>
             <a:r>
-              <a:rPr lang="en-US" smtClean="0"/>
+              <a:rPr lang="en-US"/>
               <a:t>Second level</a:t>
             </a:r>
           </a:p>
           <a:p>
             <a:pPr lvl="2"/>
             <a:r>
-              <a:rPr lang="en-US" smtClean="0"/>
+              <a:rPr lang="en-US"/>
               <a:t>Third level</a:t>
             </a:r>
           </a:p>
           <a:p>
             <a:pPr lvl="3"/>
             <a:r>
-              <a:rPr lang="en-US" smtClean="0"/>
+              <a:rPr lang="en-US"/>
               <a:t>Fourth level</a:t>
             </a:r>
           </a:p>
           <a:p>
             <a:pPr lvl="4"/>
             <a:r>
-              <a:rPr lang="en-US" smtClean="0"/>
+              <a:rPr lang="en-US"/>
               <a:t>Fifth level</a:t>
             </a:r>
-            <a:endParaRPr lang="en-US"/>
           </a:p>
         </p:txBody>
       </p:sp>
@@ -2541,38 +2324,37 @@
           <a:p>
             <a:pPr lvl="0"/>
             <a:r>
-              <a:rPr lang="en-US" smtClean="0"/>
+              <a:rPr lang="en-US"/>
               <a:t>Click to edit Master text styles</a:t>
             </a:r>
           </a:p>
           <a:p>
             <a:pPr lvl="1"/>
             <a:r>
-              <a:rPr lang="en-US" smtClean="0"/>
+              <a:rPr lang="en-US"/>
               <a:t>Second level</a:t>
             </a:r>
           </a:p>
           <a:p>
             <a:pPr lvl="2"/>
             <a:r>
-              <a:rPr lang="en-US" smtClean="0"/>
+              <a:rPr lang="en-US"/>
               <a:t>Third level</a:t>
             </a:r>
           </a:p>
           <a:p>
             <a:pPr lvl="3"/>
             <a:r>
-              <a:rPr lang="en-US" smtClean="0"/>
+              <a:rPr lang="en-US"/>
               <a:t>Fourth level</a:t>
             </a:r>
           </a:p>
           <a:p>
             <a:pPr lvl="4"/>
             <a:r>
-              <a:rPr lang="en-US" smtClean="0"/>
+              <a:rPr lang="en-US"/>
               <a:t>Fifth level</a:t>
             </a:r>
-            <a:endParaRPr lang="en-US"/>
           </a:p>
         </p:txBody>
       </p:sp>
@@ -2593,7 +2375,7 @@
           <a:p>
             <a:fld id="{5BCAD085-E8A6-8845-BD4E-CB4CCA059FC4}" type="datetimeFigureOut">
               <a:rPr lang="en-US" smtClean="0"/>
-              <a:t>1/27/13</a:t>
+              <a:t>8/13/2026</a:t>
             </a:fld>
             <a:endParaRPr lang="en-US"/>
           </a:p>
@@ -2691,10 +2473,9 @@
           </a:lstStyle>
           <a:p>
             <a:r>
-              <a:rPr lang="en-US" smtClean="0"/>
+              <a:rPr lang="en-US"/>
               <a:t>Click to edit Master title style</a:t>
             </a:r>
-            <a:endParaRPr lang="en-US"/>
           </a:p>
         </p:txBody>
       </p:sp>
@@ -2757,7 +2538,7 @@
           <a:p>
             <a:pPr lvl="0"/>
             <a:r>
-              <a:rPr lang="en-US" smtClean="0"/>
+              <a:rPr lang="en-US"/>
               <a:t>Click to edit Master text styles</a:t>
             </a:r>
           </a:p>
@@ -2813,38 +2594,37 @@
           <a:p>
             <a:pPr lvl="0"/>
             <a:r>
-              <a:rPr lang="en-US" smtClean="0"/>
+              <a:rPr lang="en-US"/>
               <a:t>Click to edit Master text styles</a:t>
             </a:r>
           </a:p>
           <a:p>
             <a:pPr lvl="1"/>
             <a:r>
-              <a:rPr lang="en-US" smtClean="0"/>
+              <a:rPr lang="en-US"/>
               <a:t>Second level</a:t>
             </a:r>
           </a:p>
           <a:p>
             <a:pPr lvl="2"/>
             <a:r>
-              <a:rPr lang="en-US" smtClean="0"/>
+              <a:rPr lang="en-US"/>
               <a:t>Third level</a:t>
             </a:r>
           </a:p>
           <a:p>
             <a:pPr lvl="3"/>
             <a:r>
-              <a:rPr lang="en-US" smtClean="0"/>
+              <a:rPr lang="en-US"/>
               <a:t>Fourth level</a:t>
             </a:r>
           </a:p>
           <a:p>
             <a:pPr lvl="4"/>
             <a:r>
-              <a:rPr lang="en-US" smtClean="0"/>
+              <a:rPr lang="en-US"/>
               <a:t>Fifth level</a:t>
             </a:r>
-            <a:endParaRPr lang="en-US"/>
           </a:p>
         </p:txBody>
       </p:sp>
@@ -2907,7 +2687,7 @@
           <a:p>
             <a:pPr lvl="0"/>
             <a:r>
-              <a:rPr lang="en-US" smtClean="0"/>
+              <a:rPr lang="en-US"/>
               <a:t>Click to edit Master text styles</a:t>
             </a:r>
           </a:p>
@@ -2963,38 +2743,37 @@
           <a:p>
             <a:pPr lvl="0"/>
             <a:r>
-              <a:rPr lang="en-US" smtClean="0"/>
+              <a:rPr lang="en-US"/>
               <a:t>Click to edit Master text styles</a:t>
             </a:r>
           </a:p>
           <a:p>
             <a:pPr lvl="1"/>
             <a:r>
-              <a:rPr lang="en-US" smtClean="0"/>
+              <a:rPr lang="en-US"/>
               <a:t>Second level</a:t>
             </a:r>
           </a:p>
           <a:p>
             <a:pPr lvl="2"/>
             <a:r>
-              <a:rPr lang="en-US" smtClean="0"/>
+              <a:rPr lang="en-US"/>
               <a:t>Third level</a:t>
             </a:r>
           </a:p>
           <a:p>
             <a:pPr lvl="3"/>
             <a:r>
-              <a:rPr lang="en-US" smtClean="0"/>
+              <a:rPr lang="en-US"/>
               <a:t>Fourth level</a:t>
             </a:r>
           </a:p>
           <a:p>
             <a:pPr lvl="4"/>
             <a:r>
-              <a:rPr lang="en-US" smtClean="0"/>
+              <a:rPr lang="en-US"/>
               <a:t>Fifth level</a:t>
             </a:r>
-            <a:endParaRPr lang="en-US"/>
           </a:p>
         </p:txBody>
       </p:sp>
@@ -3015,7 +2794,7 @@
           <a:p>
             <a:fld id="{5BCAD085-E8A6-8845-BD4E-CB4CCA059FC4}" type="datetimeFigureOut">
               <a:rPr lang="en-US" smtClean="0"/>
-              <a:t>1/27/13</a:t>
+              <a:t>8/13/2026</a:t>
             </a:fld>
             <a:endParaRPr lang="en-US"/>
           </a:p>
@@ -3109,10 +2888,9 @@
           <a:lstStyle/>
           <a:p>
             <a:r>
-              <a:rPr lang="en-US" smtClean="0"/>
+              <a:rPr lang="en-US"/>
               <a:t>Click to edit Master title style</a:t>
             </a:r>
-            <a:endParaRPr lang="en-US"/>
           </a:p>
         </p:txBody>
       </p:sp>
@@ -3133,7 +2911,7 @@
           <a:p>
             <a:fld id="{5BCAD085-E8A6-8845-BD4E-CB4CCA059FC4}" type="datetimeFigureOut">
               <a:rPr lang="en-US" smtClean="0"/>
-              <a:t>1/27/13</a:t>
+              <a:t>8/13/2026</a:t>
             </a:fld>
             <a:endParaRPr lang="en-US"/>
           </a:p>
@@ -3228,7 +3006,7 @@
           <a:p>
             <a:fld id="{5BCAD085-E8A6-8845-BD4E-CB4CCA059FC4}" type="datetimeFigureOut">
               <a:rPr lang="en-US" smtClean="0"/>
-              <a:t>1/27/13</a:t>
+              <a:t>8/13/2026</a:t>
             </a:fld>
             <a:endParaRPr lang="en-US"/>
           </a:p>
@@ -3331,10 +3109,9 @@
           </a:lstStyle>
           <a:p>
             <a:r>
-              <a:rPr lang="en-US" smtClean="0"/>
+              <a:rPr lang="en-US"/>
               <a:t>Click to edit Master title style</a:t>
             </a:r>
-            <a:endParaRPr lang="en-US"/>
           </a:p>
         </p:txBody>
       </p:sp>
@@ -3388,38 +3165,37 @@
           <a:p>
             <a:pPr lvl="0"/>
             <a:r>
-              <a:rPr lang="en-US" smtClean="0"/>
+              <a:rPr lang="en-US"/>
               <a:t>Click to edit Master text styles</a:t>
             </a:r>
           </a:p>
           <a:p>
             <a:pPr lvl="1"/>
             <a:r>
-              <a:rPr lang="en-US" smtClean="0"/>
+              <a:rPr lang="en-US"/>
               <a:t>Second level</a:t>
             </a:r>
           </a:p>
           <a:p>
             <a:pPr lvl="2"/>
             <a:r>
-              <a:rPr lang="en-US" smtClean="0"/>
+              <a:rPr lang="en-US"/>
               <a:t>Third level</a:t>
             </a:r>
           </a:p>
           <a:p>
             <a:pPr lvl="3"/>
             <a:r>
-              <a:rPr lang="en-US" smtClean="0"/>
+              <a:rPr lang="en-US"/>
               <a:t>Fourth level</a:t>
             </a:r>
           </a:p>
           <a:p>
             <a:pPr lvl="4"/>
             <a:r>
-              <a:rPr lang="en-US" smtClean="0"/>
+              <a:rPr lang="en-US"/>
               <a:t>Fifth level</a:t>
             </a:r>
-            <a:endParaRPr lang="en-US"/>
           </a:p>
         </p:txBody>
       </p:sp>
@@ -3482,7 +3258,7 @@
           <a:p>
             <a:pPr lvl="0"/>
             <a:r>
-              <a:rPr lang="en-US" smtClean="0"/>
+              <a:rPr lang="en-US"/>
               <a:t>Click to edit Master text styles</a:t>
             </a:r>
           </a:p>
@@ -3505,7 +3281,7 @@
           <a:p>
             <a:fld id="{5BCAD085-E8A6-8845-BD4E-CB4CCA059FC4}" type="datetimeFigureOut">
               <a:rPr lang="en-US" smtClean="0"/>
-              <a:t>1/27/13</a:t>
+              <a:t>8/13/2026</a:t>
             </a:fld>
             <a:endParaRPr lang="en-US"/>
           </a:p>
@@ -3608,10 +3384,9 @@
           </a:lstStyle>
           <a:p>
             <a:r>
-              <a:rPr lang="en-US" smtClean="0"/>
+              <a:rPr lang="en-US"/>
               <a:t>Click to edit Master title style</a:t>
             </a:r>
-            <a:endParaRPr lang="en-US"/>
           </a:p>
         </p:txBody>
       </p:sp>
@@ -3735,7 +3510,7 @@
           <a:p>
             <a:pPr lvl="0"/>
             <a:r>
-              <a:rPr lang="en-US" smtClean="0"/>
+              <a:rPr lang="en-US"/>
               <a:t>Click to edit Master text styles</a:t>
             </a:r>
           </a:p>
@@ -3758,7 +3533,7 @@
           <a:p>
             <a:fld id="{5BCAD085-E8A6-8845-BD4E-CB4CCA059FC4}" type="datetimeFigureOut">
               <a:rPr lang="en-US" smtClean="0"/>
-              <a:t>1/27/13</a:t>
+              <a:t>8/13/2026</a:t>
             </a:fld>
             <a:endParaRPr lang="en-US"/>
           </a:p>
@@ -3867,10 +3642,9 @@
           <a:lstStyle/>
           <a:p>
             <a:r>
-              <a:rPr lang="en-US" smtClean="0"/>
+              <a:rPr lang="en-US"/>
               <a:t>Click to edit Master title style</a:t>
             </a:r>
-            <a:endParaRPr lang="en-US"/>
           </a:p>
         </p:txBody>
       </p:sp>
@@ -3901,38 +3675,37 @@
           <a:p>
             <a:pPr lvl="0"/>
             <a:r>
-              <a:rPr lang="en-US" smtClean="0"/>
+              <a:rPr lang="en-US"/>
               <a:t>Click to edit Master text styles</a:t>
             </a:r>
           </a:p>
           <a:p>
             <a:pPr lvl="1"/>
             <a:r>
-              <a:rPr lang="en-US" smtClean="0"/>
+              <a:rPr lang="en-US"/>
               <a:t>Second level</a:t>
             </a:r>
           </a:p>
           <a:p>
             <a:pPr lvl="2"/>
             <a:r>
-              <a:rPr lang="en-US" smtClean="0"/>
+              <a:rPr lang="en-US"/>
               <a:t>Third level</a:t>
             </a:r>
           </a:p>
           <a:p>
             <a:pPr lvl="3"/>
             <a:r>
-              <a:rPr lang="en-US" smtClean="0"/>
+              <a:rPr lang="en-US"/>
               <a:t>Fourth level</a:t>
             </a:r>
           </a:p>
           <a:p>
             <a:pPr lvl="4"/>
             <a:r>
-              <a:rPr lang="en-US" smtClean="0"/>
+              <a:rPr lang="en-US"/>
               <a:t>Fifth level</a:t>
             </a:r>
-            <a:endParaRPr lang="en-US"/>
           </a:p>
         </p:txBody>
       </p:sp>
@@ -3971,7 +3744,7 @@
           <a:p>
             <a:fld id="{5BCAD085-E8A6-8845-BD4E-CB4CCA059FC4}" type="datetimeFigureOut">
               <a:rPr lang="en-US" smtClean="0"/>
-              <a:t>1/27/13</a:t>
+              <a:t>8/13/2026</a:t>
             </a:fld>
             <a:endParaRPr lang="en-US"/>
           </a:p>
@@ -4330,7 +4103,7 @@
 </file>
 
 <file path=ppt/slides/slide1.xml><?xml version="1.0" encoding="utf-8"?>
-<p:sld xmlns:a="http://schemas.openxmlformats.org/drawingml/2006/main" xmlns:p="http://schemas.openxmlformats.org/presentationml/2006/main" xmlns:r="http://schemas.openxmlformats.org/officeDocument/2006/relationships">
+<p:sld xmlns:a="http://schemas.openxmlformats.org/drawingml/2006/main" xmlns:r="http://schemas.openxmlformats.org/officeDocument/2006/relationships" xmlns:p="http://schemas.openxmlformats.org/presentationml/2006/main">
   <p:cSld>
     <p:spTree>
       <p:nvGrpSpPr>
@@ -4338,7 +4111,14 @@
         <p:cNvGrpSpPr/>
         <p:nvPr/>
       </p:nvGrpSpPr>
-      <p:grpSpPr/>
+      <p:grpSpPr>
+        <a:xfrm>
+          <a:off x="0" y="0"/>
+          <a:ext cx="0" cy="0"/>
+          <a:chOff x="0" y="0"/>
+          <a:chExt cx="0" cy="0"/>
+        </a:xfrm>
+      </p:grpSpPr>
       <p:sp>
         <p:nvSpPr>
           <p:cNvPr id="2" name="Rectangle 1"/>
@@ -4380,6 +4160,7 @@
           <a:lstStyle/>
           <a:p>
             <a:pPr algn="ctr"/>
+            <a:endParaRPr/>
           </a:p>
         </p:txBody>
       </p:sp>
@@ -4424,6 +4205,7 @@
           <a:lstStyle/>
           <a:p>
             <a:pPr algn="ctr"/>
+            <a:endParaRPr/>
           </a:p>
         </p:txBody>
       </p:sp>
@@ -4611,7 +4393,7 @@
 </file>
 
 <file path=ppt/slides/slide10.xml><?xml version="1.0" encoding="utf-8"?>
-<p:sld xmlns:a="http://schemas.openxmlformats.org/drawingml/2006/main" xmlns:p="http://schemas.openxmlformats.org/presentationml/2006/main" xmlns:r="http://schemas.openxmlformats.org/officeDocument/2006/relationships">
+<p:sld xmlns:a="http://schemas.openxmlformats.org/drawingml/2006/main" xmlns:r="http://schemas.openxmlformats.org/officeDocument/2006/relationships" xmlns:p="http://schemas.openxmlformats.org/presentationml/2006/main">
   <p:cSld>
     <p:spTree>
       <p:nvGrpSpPr>
@@ -4619,7 +4401,14 @@
         <p:cNvGrpSpPr/>
         <p:nvPr/>
       </p:nvGrpSpPr>
-      <p:grpSpPr/>
+      <p:grpSpPr>
+        <a:xfrm>
+          <a:off x="0" y="0"/>
+          <a:ext cx="0" cy="0"/>
+          <a:chOff x="0" y="0"/>
+          <a:chExt cx="0" cy="0"/>
+        </a:xfrm>
+      </p:grpSpPr>
       <p:sp>
         <p:nvSpPr>
           <p:cNvPr id="2" name="Rectangle 1"/>
@@ -4661,6 +4450,7 @@
           <a:lstStyle/>
           <a:p>
             <a:pPr algn="ctr"/>
+            <a:endParaRPr/>
           </a:p>
         </p:txBody>
       </p:sp>
@@ -4705,6 +4495,7 @@
           <a:lstStyle/>
           <a:p>
             <a:pPr algn="ctr"/>
+            <a:endParaRPr/>
           </a:p>
         </p:txBody>
       </p:sp>
@@ -4819,6 +4610,7 @@
           <a:lstStyle/>
           <a:p>
             <a:pPr algn="ctr"/>
+            <a:endParaRPr/>
           </a:p>
         </p:txBody>
       </p:sp>
@@ -4899,6 +4691,7 @@
           <a:lstStyle/>
           <a:p>
             <a:pPr algn="ctr"/>
+            <a:endParaRPr/>
           </a:p>
         </p:txBody>
       </p:sp>
@@ -4979,6 +4772,7 @@
           <a:lstStyle/>
           <a:p>
             <a:pPr algn="ctr"/>
+            <a:endParaRPr/>
           </a:p>
         </p:txBody>
       </p:sp>
@@ -5046,7 +4840,7 @@
               </a:spcAft>
             </a:pPr>
             <a:r>
-              <a:rPr b="1" sz="1500">
+              <a:rPr sz="1500" b="1">
                 <a:solidFill>
                   <a:srgbClr val="1B2838"/>
                 </a:solidFill>
@@ -5071,7 +4865,7 @@
               </a:spcAft>
             </a:pPr>
             <a:r>
-              <a:rPr b="1" sz="1500">
+              <a:rPr sz="1500" b="1">
                 <a:solidFill>
                   <a:srgbClr val="1B2838"/>
                 </a:solidFill>
@@ -5096,7 +4890,7 @@
               </a:spcAft>
             </a:pPr>
             <a:r>
-              <a:rPr b="1" sz="1500">
+              <a:rPr sz="1500" b="1">
                 <a:solidFill>
                   <a:srgbClr val="1B2838"/>
                 </a:solidFill>
@@ -5121,7 +4915,7 @@
               </a:spcAft>
             </a:pPr>
             <a:r>
-              <a:rPr b="1" sz="1500">
+              <a:rPr sz="1500" b="1">
                 <a:solidFill>
                   <a:srgbClr val="1B2838"/>
                 </a:solidFill>
@@ -5146,7 +4940,7 @@
               </a:spcAft>
             </a:pPr>
             <a:r>
-              <a:rPr b="1" sz="1500">
+              <a:rPr sz="1500" b="1">
                 <a:solidFill>
                   <a:srgbClr val="1B2838"/>
                 </a:solidFill>
@@ -5207,6 +5001,7 @@
           <a:lstStyle/>
           <a:p>
             <a:pPr algn="ctr"/>
+            <a:endParaRPr/>
           </a:p>
         </p:txBody>
       </p:sp>
@@ -5273,13 +5068,49 @@
               </a:spcAft>
             </a:pPr>
             <a:r>
-              <a:rPr sz="1300">
-                <a:solidFill>
-                  <a:srgbClr val="1F2A36"/>
-                </a:solidFill>
-                <a:latin typeface="Calibri"/>
-              </a:rPr>
-              <a:t>▪ voted_up, steam_purchase → bool</a:t>
+              <a:rPr sz="1300" dirty="0">
+                <a:solidFill>
+                  <a:srgbClr val="1F2A36"/>
+                </a:solidFill>
+                <a:latin typeface="Calibri"/>
+              </a:rPr>
+              <a:t>▪ </a:t>
+            </a:r>
+            <a:r>
+              <a:rPr sz="1300" dirty="0" err="1">
+                <a:solidFill>
+                  <a:srgbClr val="1F2A36"/>
+                </a:solidFill>
+                <a:latin typeface="Calibri"/>
+              </a:rPr>
+              <a:t>voted_up</a:t>
+            </a:r>
+            <a:r>
+              <a:rPr sz="1300" dirty="0">
+                <a:solidFill>
+                  <a:srgbClr val="1F2A36"/>
+                </a:solidFill>
+                <a:latin typeface="Calibri"/>
+              </a:rPr>
+              <a:t>, </a:t>
+            </a:r>
+            <a:r>
+              <a:rPr sz="1300" dirty="0" err="1">
+                <a:solidFill>
+                  <a:srgbClr val="1F2A36"/>
+                </a:solidFill>
+                <a:latin typeface="Calibri"/>
+              </a:rPr>
+              <a:t>steam_purchase</a:t>
+            </a:r>
+            <a:r>
+              <a:rPr sz="1300" dirty="0">
+                <a:solidFill>
+                  <a:srgbClr val="1F2A36"/>
+                </a:solidFill>
+                <a:latin typeface="Calibri"/>
+              </a:rPr>
+              <a:t> → bool</a:t>
             </a:r>
           </a:p>
           <a:p>
@@ -5289,13 +5120,31 @@
               </a:spcAft>
             </a:pPr>
             <a:r>
-              <a:rPr sz="1300">
-                <a:solidFill>
-                  <a:srgbClr val="1F2A36"/>
-                </a:solidFill>
-                <a:latin typeface="Calibri"/>
-              </a:rPr>
-              <a:t>▪ playtime → float (NaN → 0)</a:t>
+              <a:rPr sz="1300" dirty="0">
+                <a:solidFill>
+                  <a:srgbClr val="1F2A36"/>
+                </a:solidFill>
+                <a:latin typeface="Calibri"/>
+              </a:rPr>
+              <a:t>▪ playtime → float (</a:t>
+            </a:r>
+            <a:r>
+              <a:rPr sz="1300" dirty="0" err="1">
+                <a:solidFill>
+                  <a:srgbClr val="1F2A36"/>
+                </a:solidFill>
+                <a:latin typeface="Calibri"/>
+              </a:rPr>
+              <a:t>NaN</a:t>
+            </a:r>
+            <a:r>
+              <a:rPr sz="1300" dirty="0">
+                <a:solidFill>
+                  <a:srgbClr val="1F2A36"/>
+                </a:solidFill>
+                <a:latin typeface="Calibri"/>
+              </a:rPr>
+              <a:t> → 0)</a:t>
             </a:r>
           </a:p>
           <a:p>
@@ -5305,14 +5154,83 @@
               </a:spcAft>
             </a:pPr>
             <a:r>
-              <a:rPr sz="1300">
-                <a:solidFill>
-                  <a:srgbClr val="1F2A36"/>
-                </a:solidFill>
-                <a:latin typeface="Calibri"/>
-              </a:rPr>
-              <a:t>▪ tydstempel → numeries, geldig vereis</a:t>
-            </a:r>
+              <a:rPr sz="1300" dirty="0">
+                <a:solidFill>
+                  <a:srgbClr val="1F2A36"/>
+                </a:solidFill>
+                <a:latin typeface="Calibri"/>
+              </a:rPr>
+              <a:t>▪ </a:t>
+            </a:r>
+            <a:r>
+              <a:rPr sz="1300" dirty="0" err="1">
+                <a:solidFill>
+                  <a:srgbClr val="1F2A36"/>
+                </a:solidFill>
+                <a:latin typeface="Calibri"/>
+              </a:rPr>
+              <a:t>tydstempel</a:t>
+            </a:r>
+            <a:r>
+              <a:rPr sz="1300" dirty="0">
+                <a:solidFill>
+                  <a:srgbClr val="1F2A36"/>
+                </a:solidFill>
+                <a:latin typeface="Calibri"/>
+              </a:rPr>
+              <a:t> → </a:t>
+            </a:r>
+            <a:r>
+              <a:rPr sz="1300" dirty="0" err="1">
+                <a:solidFill>
+                  <a:srgbClr val="1F2A36"/>
+                </a:solidFill>
+                <a:latin typeface="Calibri"/>
+              </a:rPr>
+              <a:t>numeries</a:t>
+            </a:r>
+            <a:r>
+              <a:rPr sz="1300" dirty="0">
+                <a:solidFill>
+                  <a:srgbClr val="1F2A36"/>
+                </a:solidFill>
+                <a:latin typeface="Calibri"/>
+              </a:rPr>
+              <a:t>, </a:t>
+            </a:r>
+            <a:r>
+              <a:rPr sz="1300" dirty="0" err="1">
+                <a:solidFill>
+                  <a:srgbClr val="1F2A36"/>
+                </a:solidFill>
+                <a:latin typeface="Calibri"/>
+              </a:rPr>
+              <a:t>geldig</a:t>
+            </a:r>
+            <a:r>
+              <a:rPr sz="1300" dirty="0">
+                <a:solidFill>
+                  <a:srgbClr val="1F2A36"/>
+                </a:solidFill>
+                <a:latin typeface="Calibri"/>
+              </a:rPr>
+              <a:t> </a:t>
+            </a:r>
+            <a:r>
+              <a:rPr sz="1300" dirty="0" err="1">
+                <a:solidFill>
+                  <a:srgbClr val="1F2A36"/>
+                </a:solidFill>
+                <a:latin typeface="Calibri"/>
+              </a:rPr>
+              <a:t>vereis</a:t>
+            </a:r>
+            <a:endParaRPr sz="1300" dirty="0">
+              <a:solidFill>
+                <a:srgbClr val="1F2A36"/>
+              </a:solidFill>
+              <a:latin typeface="Calibri"/>
+            </a:endParaRPr>
           </a:p>
           <a:p>
             <a:pPr>
@@ -5321,7 +5239,7 @@
               </a:spcAft>
             </a:pPr>
             <a:r>
-              <a:rPr sz="1300">
+              <a:rPr sz="1300" dirty="0">
                 <a:solidFill>
                   <a:srgbClr val="1F2A36"/>
                 </a:solidFill>
@@ -5337,14 +5255,83 @@
               </a:spcAft>
             </a:pPr>
             <a:r>
-              <a:rPr sz="1300">
-                <a:solidFill>
-                  <a:srgbClr val="1F2A36"/>
-                </a:solidFill>
-                <a:latin typeface="Calibri"/>
-              </a:rPr>
-              <a:t>▪ geen ontbrekende kernwaardes oor</a:t>
-            </a:r>
+              <a:rPr sz="1300" dirty="0">
+                <a:solidFill>
+                  <a:srgbClr val="1F2A36"/>
+                </a:solidFill>
+                <a:latin typeface="Calibri"/>
+              </a:rPr>
+              <a:t>▪ </a:t>
+            </a:r>
+            <a:r>
+              <a:rPr sz="1300" dirty="0" err="1">
+                <a:solidFill>
+                  <a:srgbClr val="1F2A36"/>
+                </a:solidFill>
+                <a:latin typeface="Calibri"/>
+              </a:rPr>
+              <a:t>geen</a:t>
+            </a:r>
+            <a:r>
+              <a:rPr sz="1300" dirty="0">
+                <a:solidFill>
+                  <a:srgbClr val="1F2A36"/>
+                </a:solidFill>
+                <a:latin typeface="Calibri"/>
+              </a:rPr>
+              <a:t> </a:t>
+            </a:r>
+            <a:r>
+              <a:rPr sz="1300" dirty="0" err="1">
+                <a:solidFill>
+                  <a:srgbClr val="1F2A36"/>
+                </a:solidFill>
+                <a:latin typeface="Calibri"/>
+              </a:rPr>
+              <a:t>ontbrekende</a:t>
+            </a:r>
+            <a:r>
+              <a:rPr sz="1300" dirty="0">
+                <a:solidFill>
+                  <a:srgbClr val="1F2A36"/>
+                </a:solidFill>
+                <a:latin typeface="Calibri"/>
+              </a:rPr>
+              <a:t> </a:t>
+            </a:r>
+            <a:r>
+              <a:rPr sz="1300" dirty="0" err="1">
+                <a:solidFill>
+                  <a:srgbClr val="1F2A36"/>
+                </a:solidFill>
+                <a:latin typeface="Calibri"/>
+              </a:rPr>
+              <a:t>kernwaardes</a:t>
+            </a:r>
+            <a:r>
+              <a:rPr sz="1300" dirty="0">
+                <a:solidFill>
+                  <a:srgbClr val="1F2A36"/>
+                </a:solidFill>
+                <a:latin typeface="Calibri"/>
+              </a:rPr>
+              <a:t> </a:t>
+            </a:r>
+            <a:r>
+              <a:rPr sz="1300" dirty="0" err="1">
+                <a:solidFill>
+                  <a:srgbClr val="1F2A36"/>
+                </a:solidFill>
+                <a:latin typeface="Calibri"/>
+              </a:rPr>
+              <a:t>oor</a:t>
+            </a:r>
+            <a:endParaRPr sz="1300" dirty="0">
+              <a:solidFill>
+                <a:srgbClr val="1F2A36"/>
+              </a:solidFill>
+              <a:latin typeface="Calibri"/>
+            </a:endParaRPr>
           </a:p>
         </p:txBody>
       </p:sp>
@@ -5357,7 +5344,7 @@
 </file>
 
 <file path=ppt/slides/slide11.xml><?xml version="1.0" encoding="utf-8"?>
-<p:sld xmlns:a="http://schemas.openxmlformats.org/drawingml/2006/main" xmlns:p="http://schemas.openxmlformats.org/presentationml/2006/main" xmlns:r="http://schemas.openxmlformats.org/officeDocument/2006/relationships">
+<p:sld xmlns:a="http://schemas.openxmlformats.org/drawingml/2006/main" xmlns:r="http://schemas.openxmlformats.org/officeDocument/2006/relationships" xmlns:p="http://schemas.openxmlformats.org/presentationml/2006/main">
   <p:cSld>
     <p:spTree>
       <p:nvGrpSpPr>
@@ -5365,7 +5352,14 @@
         <p:cNvGrpSpPr/>
         <p:nvPr/>
       </p:nvGrpSpPr>
-      <p:grpSpPr/>
+      <p:grpSpPr>
+        <a:xfrm>
+          <a:off x="0" y="0"/>
+          <a:ext cx="0" cy="0"/>
+          <a:chOff x="0" y="0"/>
+          <a:chExt cx="0" cy="0"/>
+        </a:xfrm>
+      </p:grpSpPr>
       <p:sp>
         <p:nvSpPr>
           <p:cNvPr id="2" name="Rectangle 1"/>
@@ -5407,6 +5401,7 @@
           <a:lstStyle/>
           <a:p>
             <a:pPr algn="ctr"/>
+            <a:endParaRPr/>
           </a:p>
         </p:txBody>
       </p:sp>
@@ -5451,6 +5446,7 @@
           <a:lstStyle/>
           <a:p>
             <a:pPr algn="ctr"/>
+            <a:endParaRPr/>
           </a:p>
         </p:txBody>
       </p:sp>
@@ -5533,7 +5529,7 @@
           <p:nvPr/>
         </p:nvPicPr>
         <p:blipFill>
-          <a:blip r:embed="rId2"/>
+          <a:blip r:embed="rId3"/>
           <a:stretch>
             <a:fillRect/>
           </a:stretch>
@@ -5576,7 +5572,7 @@
               </a:spcAft>
             </a:pPr>
             <a:r>
-              <a:rPr b="1" sz="1500">
+              <a:rPr sz="1500" b="1">
                 <a:solidFill>
                   <a:srgbClr val="1B2838"/>
                 </a:solidFill>
@@ -5601,7 +5597,7 @@
               </a:spcAft>
             </a:pPr>
             <a:r>
-              <a:rPr b="1" sz="1500">
+              <a:rPr sz="1500" b="1">
                 <a:solidFill>
                   <a:srgbClr val="1B2838"/>
                 </a:solidFill>
@@ -5626,7 +5622,7 @@
               </a:spcAft>
             </a:pPr>
             <a:r>
-              <a:rPr b="1" sz="1500">
+              <a:rPr sz="1500" b="1">
                 <a:solidFill>
                   <a:srgbClr val="1B2838"/>
                 </a:solidFill>
@@ -5655,7 +5651,7 @@
 </file>
 
 <file path=ppt/slides/slide12.xml><?xml version="1.0" encoding="utf-8"?>
-<p:sld xmlns:a="http://schemas.openxmlformats.org/drawingml/2006/main" xmlns:p="http://schemas.openxmlformats.org/presentationml/2006/main" xmlns:r="http://schemas.openxmlformats.org/officeDocument/2006/relationships">
+<p:sld xmlns:a="http://schemas.openxmlformats.org/drawingml/2006/main" xmlns:r="http://schemas.openxmlformats.org/officeDocument/2006/relationships" xmlns:p="http://schemas.openxmlformats.org/presentationml/2006/main">
   <p:cSld>
     <p:spTree>
       <p:nvGrpSpPr>
@@ -5663,7 +5659,14 @@
         <p:cNvGrpSpPr/>
         <p:nvPr/>
       </p:nvGrpSpPr>
-      <p:grpSpPr/>
+      <p:grpSpPr>
+        <a:xfrm>
+          <a:off x="0" y="0"/>
+          <a:ext cx="0" cy="0"/>
+          <a:chOff x="0" y="0"/>
+          <a:chExt cx="0" cy="0"/>
+        </a:xfrm>
+      </p:grpSpPr>
       <p:sp>
         <p:nvSpPr>
           <p:cNvPr id="2" name="Rectangle 1"/>
@@ -5705,6 +5708,7 @@
           <a:lstStyle/>
           <a:p>
             <a:pPr algn="ctr"/>
+            <a:endParaRPr/>
           </a:p>
         </p:txBody>
       </p:sp>
@@ -5749,6 +5753,7 @@
           <a:lstStyle/>
           <a:p>
             <a:pPr algn="ctr"/>
+            <a:endParaRPr/>
           </a:p>
         </p:txBody>
       </p:sp>
@@ -5863,6 +5868,7 @@
           <a:lstStyle/>
           <a:p>
             <a:pPr algn="ctr"/>
+            <a:endParaRPr/>
           </a:p>
         </p:txBody>
       </p:sp>
@@ -6029,6 +6035,7 @@
           <a:lstStyle/>
           <a:p>
             <a:pPr algn="ctr"/>
+            <a:endParaRPr/>
           </a:p>
         </p:txBody>
       </p:sp>
@@ -6095,7 +6102,7 @@
               </a:spcAft>
             </a:pPr>
             <a:r>
-              <a:rPr b="1" sz="1400">
+              <a:rPr sz="1400" b="1">
                 <a:solidFill>
                   <a:srgbClr val="1B2838"/>
                 </a:solidFill>
@@ -6120,22 +6127,13 @@
               </a:spcAft>
             </a:pPr>
             <a:r>
-              <a:rPr b="1" sz="1400">
+              <a:rPr sz="1400" b="1">
                 <a:solidFill>
                   <a:srgbClr val="1B2838"/>
                 </a:solidFill>
                 <a:latin typeface="Calibri"/>
               </a:rPr>
               <a:t>▪ 33 speletjies · 9 genres · 30 tale</a:t>
-            </a:r>
-            <a:r>
-              <a:rPr sz="1400">
-                <a:solidFill>
-                  <a:srgbClr val="1F2A36"/>
-                </a:solidFill>
-                <a:latin typeface="Calibri"/>
-              </a:rPr>
-              <a:t/>
             </a:r>
           </a:p>
           <a:p>
@@ -6145,22 +6143,13 @@
               </a:spcAft>
             </a:pPr>
             <a:r>
-              <a:rPr b="1" sz="1400">
+              <a:rPr sz="1400" b="1">
                 <a:solidFill>
                   <a:srgbClr val="1B2838"/>
                 </a:solidFill>
                 <a:latin typeface="Calibri"/>
               </a:rPr>
               <a:t>▪ Steam API-webskraping, volledig gedokumenteer</a:t>
-            </a:r>
-            <a:r>
-              <a:rPr sz="1400">
-                <a:solidFill>
-                  <a:srgbClr val="1F2A36"/>
-                </a:solidFill>
-                <a:latin typeface="Calibri"/>
-              </a:rPr>
-              <a:t/>
             </a:r>
           </a:p>
           <a:p>
@@ -6170,7 +6159,7 @@
               </a:spcAft>
             </a:pPr>
             <a:r>
-              <a:rPr b="1" sz="1400">
+              <a:rPr sz="1400" b="1">
                 <a:solidFill>
                   <a:srgbClr val="1B2838"/>
                 </a:solidFill>
@@ -6231,6 +6220,7 @@
           <a:lstStyle/>
           <a:p>
             <a:pPr algn="ctr"/>
+            <a:endParaRPr/>
           </a:p>
         </p:txBody>
       </p:sp>
@@ -6278,7 +6268,7 @@
 </file>
 
 <file path=ppt/slides/slide2.xml><?xml version="1.0" encoding="utf-8"?>
-<p:sld xmlns:a="http://schemas.openxmlformats.org/drawingml/2006/main" xmlns:p="http://schemas.openxmlformats.org/presentationml/2006/main" xmlns:r="http://schemas.openxmlformats.org/officeDocument/2006/relationships">
+<p:sld xmlns:a="http://schemas.openxmlformats.org/drawingml/2006/main" xmlns:r="http://schemas.openxmlformats.org/officeDocument/2006/relationships" xmlns:p="http://schemas.openxmlformats.org/presentationml/2006/main">
   <p:cSld>
     <p:spTree>
       <p:nvGrpSpPr>
@@ -6286,7 +6276,14 @@
         <p:cNvGrpSpPr/>
         <p:nvPr/>
       </p:nvGrpSpPr>
-      <p:grpSpPr/>
+      <p:grpSpPr>
+        <a:xfrm>
+          <a:off x="0" y="0"/>
+          <a:ext cx="0" cy="0"/>
+          <a:chOff x="0" y="0"/>
+          <a:chExt cx="0" cy="0"/>
+        </a:xfrm>
+      </p:grpSpPr>
       <p:sp>
         <p:nvSpPr>
           <p:cNvPr id="2" name="Rectangle 1"/>
@@ -6328,6 +6325,7 @@
           <a:lstStyle/>
           <a:p>
             <a:pPr algn="ctr"/>
+            <a:endParaRPr/>
           </a:p>
         </p:txBody>
       </p:sp>
@@ -6372,6 +6370,7 @@
           <a:lstStyle/>
           <a:p>
             <a:pPr algn="ctr"/>
+            <a:endParaRPr/>
           </a:p>
         </p:txBody>
       </p:sp>
@@ -6473,7 +6472,7 @@
               </a:spcAft>
             </a:pPr>
             <a:r>
-              <a:rPr b="1" sz="1700">
+              <a:rPr sz="1700" b="1">
                 <a:solidFill>
                   <a:srgbClr val="1B2838"/>
                 </a:solidFill>
@@ -6498,7 +6497,7 @@
               </a:spcAft>
             </a:pPr>
             <a:r>
-              <a:rPr b="1" sz="1700">
+              <a:rPr sz="1700" b="1">
                 <a:solidFill>
                   <a:srgbClr val="1B2838"/>
                 </a:solidFill>
@@ -6523,7 +6522,7 @@
               </a:spcAft>
             </a:pPr>
             <a:r>
-              <a:rPr b="1" sz="1700">
+              <a:rPr sz="1700" b="1">
                 <a:solidFill>
                   <a:srgbClr val="1B2838"/>
                 </a:solidFill>
@@ -6548,7 +6547,7 @@
               </a:spcAft>
             </a:pPr>
             <a:r>
-              <a:rPr b="1" sz="1700">
+              <a:rPr sz="1700" b="1">
                 <a:solidFill>
                   <a:srgbClr val="1B2838"/>
                 </a:solidFill>
@@ -6573,7 +6572,7 @@
               </a:spcAft>
             </a:pPr>
             <a:r>
-              <a:rPr b="1" sz="1700">
+              <a:rPr sz="1700" b="1">
                 <a:solidFill>
                   <a:srgbClr val="1B2838"/>
                 </a:solidFill>
@@ -6634,6 +6633,7 @@
           <a:lstStyle/>
           <a:p>
             <a:pPr algn="ctr"/>
+            <a:endParaRPr/>
           </a:p>
         </p:txBody>
       </p:sp>
@@ -6800,7 +6800,7 @@
 </file>
 
 <file path=ppt/slides/slide3.xml><?xml version="1.0" encoding="utf-8"?>
-<p:sld xmlns:a="http://schemas.openxmlformats.org/drawingml/2006/main" xmlns:p="http://schemas.openxmlformats.org/presentationml/2006/main" xmlns:r="http://schemas.openxmlformats.org/officeDocument/2006/relationships">
+<p:sld xmlns:a="http://schemas.openxmlformats.org/drawingml/2006/main" xmlns:r="http://schemas.openxmlformats.org/officeDocument/2006/relationships" xmlns:p="http://schemas.openxmlformats.org/presentationml/2006/main">
   <p:cSld>
     <p:spTree>
       <p:nvGrpSpPr>
@@ -6808,7 +6808,14 @@
         <p:cNvGrpSpPr/>
         <p:nvPr/>
       </p:nvGrpSpPr>
-      <p:grpSpPr/>
+      <p:grpSpPr>
+        <a:xfrm>
+          <a:off x="0" y="0"/>
+          <a:ext cx="0" cy="0"/>
+          <a:chOff x="0" y="0"/>
+          <a:chExt cx="0" cy="0"/>
+        </a:xfrm>
+      </p:grpSpPr>
       <p:sp>
         <p:nvSpPr>
           <p:cNvPr id="2" name="Rectangle 1"/>
@@ -6850,6 +6857,7 @@
           <a:lstStyle/>
           <a:p>
             <a:pPr algn="ctr"/>
+            <a:endParaRPr/>
           </a:p>
         </p:txBody>
       </p:sp>
@@ -6894,6 +6902,7 @@
           <a:lstStyle/>
           <a:p>
             <a:pPr algn="ctr"/>
+            <a:endParaRPr/>
           </a:p>
         </p:txBody>
       </p:sp>
@@ -6995,7 +7004,7 @@
               </a:spcAft>
             </a:pPr>
             <a:r>
-              <a:rPr b="1" sz="1600">
+              <a:rPr sz="1600" b="1">
                 <a:solidFill>
                   <a:srgbClr val="1B2838"/>
                 </a:solidFill>
@@ -7020,7 +7029,7 @@
               </a:spcAft>
             </a:pPr>
             <a:r>
-              <a:rPr b="1" sz="1600">
+              <a:rPr sz="1600" b="1">
                 <a:solidFill>
                   <a:srgbClr val="1B2838"/>
                 </a:solidFill>
@@ -7045,7 +7054,7 @@
               </a:spcAft>
             </a:pPr>
             <a:r>
-              <a:rPr b="1" sz="1600">
+              <a:rPr sz="1600" b="1">
                 <a:solidFill>
                   <a:srgbClr val="1B2838"/>
                 </a:solidFill>
@@ -7106,6 +7115,7 @@
           <a:lstStyle/>
           <a:p>
             <a:pPr algn="ctr"/>
+            <a:endParaRPr/>
           </a:p>
         </p:txBody>
       </p:sp>
@@ -7256,6 +7266,7 @@
           <a:lstStyle/>
           <a:p>
             <a:pPr algn="ctr"/>
+            <a:endParaRPr/>
           </a:p>
         </p:txBody>
       </p:sp>
@@ -7406,7 +7417,7 @@
 </file>
 
 <file path=ppt/slides/slide4.xml><?xml version="1.0" encoding="utf-8"?>
-<p:sld xmlns:a="http://schemas.openxmlformats.org/drawingml/2006/main" xmlns:p="http://schemas.openxmlformats.org/presentationml/2006/main" xmlns:r="http://schemas.openxmlformats.org/officeDocument/2006/relationships">
+<p:sld xmlns:a="http://schemas.openxmlformats.org/drawingml/2006/main" xmlns:r="http://schemas.openxmlformats.org/officeDocument/2006/relationships" xmlns:p="http://schemas.openxmlformats.org/presentationml/2006/main">
   <p:cSld>
     <p:spTree>
       <p:nvGrpSpPr>
@@ -7414,7 +7425,14 @@
         <p:cNvGrpSpPr/>
         <p:nvPr/>
       </p:nvGrpSpPr>
-      <p:grpSpPr/>
+      <p:grpSpPr>
+        <a:xfrm>
+          <a:off x="0" y="0"/>
+          <a:ext cx="0" cy="0"/>
+          <a:chOff x="0" y="0"/>
+          <a:chExt cx="0" cy="0"/>
+        </a:xfrm>
+      </p:grpSpPr>
       <p:sp>
         <p:nvSpPr>
           <p:cNvPr id="2" name="Rectangle 1"/>
@@ -7456,6 +7474,7 @@
           <a:lstStyle/>
           <a:p>
             <a:pPr algn="ctr"/>
+            <a:endParaRPr/>
           </a:p>
         </p:txBody>
       </p:sp>
@@ -7500,6 +7519,7 @@
           <a:lstStyle/>
           <a:p>
             <a:pPr algn="ctr"/>
+            <a:endParaRPr/>
           </a:p>
         </p:txBody>
       </p:sp>
@@ -7601,7 +7621,7 @@
               </a:spcAft>
             </a:pPr>
             <a:r>
-              <a:rPr b="1" sz="1600">
+              <a:rPr sz="1600" b="1">
                 <a:solidFill>
                   <a:srgbClr val="1B2838"/>
                 </a:solidFill>
@@ -7626,7 +7646,7 @@
               </a:spcAft>
             </a:pPr>
             <a:r>
-              <a:rPr b="1" sz="1600">
+              <a:rPr sz="1600" b="1">
                 <a:solidFill>
                   <a:srgbClr val="1B2838"/>
                 </a:solidFill>
@@ -7651,7 +7671,7 @@
               </a:spcAft>
             </a:pPr>
             <a:r>
-              <a:rPr b="1" sz="1600">
+              <a:rPr sz="1600" b="1">
                 <a:solidFill>
                   <a:srgbClr val="1B2838"/>
                 </a:solidFill>
@@ -7676,7 +7696,7 @@
               </a:spcAft>
             </a:pPr>
             <a:r>
-              <a:rPr b="1" sz="1600">
+              <a:rPr sz="1600" b="1">
                 <a:solidFill>
                   <a:srgbClr val="1B2838"/>
                 </a:solidFill>
@@ -7737,6 +7757,7 @@
           <a:lstStyle/>
           <a:p>
             <a:pPr algn="ctr"/>
+            <a:endParaRPr/>
           </a:p>
         </p:txBody>
       </p:sp>
@@ -7858,7 +7879,7 @@
 </file>
 
 <file path=ppt/slides/slide5.xml><?xml version="1.0" encoding="utf-8"?>
-<p:sld xmlns:a="http://schemas.openxmlformats.org/drawingml/2006/main" xmlns:p="http://schemas.openxmlformats.org/presentationml/2006/main" xmlns:r="http://schemas.openxmlformats.org/officeDocument/2006/relationships">
+<p:sld xmlns:a="http://schemas.openxmlformats.org/drawingml/2006/main" xmlns:r="http://schemas.openxmlformats.org/officeDocument/2006/relationships" xmlns:p="http://schemas.openxmlformats.org/presentationml/2006/main">
   <p:cSld>
     <p:spTree>
       <p:nvGrpSpPr>
@@ -7866,7 +7887,14 @@
         <p:cNvGrpSpPr/>
         <p:nvPr/>
       </p:nvGrpSpPr>
-      <p:grpSpPr/>
+      <p:grpSpPr>
+        <a:xfrm>
+          <a:off x="0" y="0"/>
+          <a:ext cx="0" cy="0"/>
+          <a:chOff x="0" y="0"/>
+          <a:chExt cx="0" cy="0"/>
+        </a:xfrm>
+      </p:grpSpPr>
       <p:sp>
         <p:nvSpPr>
           <p:cNvPr id="2" name="Rectangle 1"/>
@@ -7908,6 +7936,7 @@
           <a:lstStyle/>
           <a:p>
             <a:pPr algn="ctr"/>
+            <a:endParaRPr/>
           </a:p>
         </p:txBody>
       </p:sp>
@@ -7952,6 +7981,7 @@
           <a:lstStyle/>
           <a:p>
             <a:pPr algn="ctr"/>
+            <a:endParaRPr/>
           </a:p>
         </p:txBody>
       </p:sp>
@@ -8066,6 +8096,7 @@
           <a:lstStyle/>
           <a:p>
             <a:pPr algn="ctr"/>
+            <a:endParaRPr/>
           </a:p>
         </p:txBody>
       </p:sp>
@@ -8146,6 +8177,7 @@
           <a:lstStyle/>
           <a:p>
             <a:pPr algn="ctr"/>
+            <a:endParaRPr/>
           </a:p>
         </p:txBody>
       </p:sp>
@@ -8226,6 +8258,7 @@
           <a:lstStyle/>
           <a:p>
             <a:pPr algn="ctr"/>
+            <a:endParaRPr/>
           </a:p>
         </p:txBody>
       </p:sp>
@@ -8293,7 +8326,7 @@
               </a:spcAft>
             </a:pPr>
             <a:r>
-              <a:rPr b="1" sz="1600">
+              <a:rPr sz="1600" b="1">
                 <a:solidFill>
                   <a:srgbClr val="1B2838"/>
                 </a:solidFill>
@@ -8318,7 +8351,7 @@
               </a:spcAft>
             </a:pPr>
             <a:r>
-              <a:rPr b="1" sz="1600">
+              <a:rPr sz="1600" b="1">
                 <a:solidFill>
                   <a:srgbClr val="1B2838"/>
                 </a:solidFill>
@@ -8343,7 +8376,7 @@
               </a:spcAft>
             </a:pPr>
             <a:r>
-              <a:rPr b="1" sz="1600">
+              <a:rPr sz="1600" b="1">
                 <a:solidFill>
                   <a:srgbClr val="1B2838"/>
                 </a:solidFill>
@@ -8368,7 +8401,7 @@
               </a:spcAft>
             </a:pPr>
             <a:r>
-              <a:rPr b="1" sz="1600">
+              <a:rPr sz="1600" b="1">
                 <a:solidFill>
                   <a:srgbClr val="1B2838"/>
                 </a:solidFill>
@@ -8429,6 +8462,7 @@
           <a:lstStyle/>
           <a:p>
             <a:pPr algn="ctr"/>
+            <a:endParaRPr/>
           </a:p>
         </p:txBody>
       </p:sp>
@@ -8547,7 +8581,7 @@
 </file>
 
 <file path=ppt/slides/slide6.xml><?xml version="1.0" encoding="utf-8"?>
-<p:sld xmlns:a="http://schemas.openxmlformats.org/drawingml/2006/main" xmlns:p="http://schemas.openxmlformats.org/presentationml/2006/main" xmlns:r="http://schemas.openxmlformats.org/officeDocument/2006/relationships">
+<p:sld xmlns:a="http://schemas.openxmlformats.org/drawingml/2006/main" xmlns:r="http://schemas.openxmlformats.org/officeDocument/2006/relationships" xmlns:p="http://schemas.openxmlformats.org/presentationml/2006/main">
   <p:cSld>
     <p:spTree>
       <p:nvGrpSpPr>
@@ -8555,7 +8589,14 @@
         <p:cNvGrpSpPr/>
         <p:nvPr/>
       </p:nvGrpSpPr>
-      <p:grpSpPr/>
+      <p:grpSpPr>
+        <a:xfrm>
+          <a:off x="0" y="0"/>
+          <a:ext cx="0" cy="0"/>
+          <a:chOff x="0" y="0"/>
+          <a:chExt cx="0" cy="0"/>
+        </a:xfrm>
+      </p:grpSpPr>
       <p:sp>
         <p:nvSpPr>
           <p:cNvPr id="2" name="Rectangle 1"/>
@@ -8597,6 +8638,7 @@
           <a:lstStyle/>
           <a:p>
             <a:pPr algn="ctr"/>
+            <a:endParaRPr/>
           </a:p>
         </p:txBody>
       </p:sp>
@@ -8641,6 +8683,7 @@
           <a:lstStyle/>
           <a:p>
             <a:pPr algn="ctr"/>
+            <a:endParaRPr/>
           </a:p>
         </p:txBody>
       </p:sp>
@@ -8755,6 +8798,7 @@
           <a:lstStyle/>
           <a:p>
             <a:pPr algn="ctr"/>
+            <a:endParaRPr/>
           </a:p>
         </p:txBody>
       </p:sp>
@@ -8835,6 +8879,7 @@
           <a:lstStyle/>
           <a:p>
             <a:pPr algn="ctr"/>
+            <a:endParaRPr/>
           </a:p>
         </p:txBody>
       </p:sp>
@@ -8915,6 +8960,7 @@
           <a:lstStyle/>
           <a:p>
             <a:pPr algn="ctr"/>
+            <a:endParaRPr/>
           </a:p>
         </p:txBody>
       </p:sp>
@@ -8995,6 +9041,7 @@
           <a:lstStyle/>
           <a:p>
             <a:pPr algn="ctr"/>
+            <a:endParaRPr/>
           </a:p>
         </p:txBody>
       </p:sp>
@@ -9043,7 +9090,7 @@
           <p:nvPr/>
         </p:nvPicPr>
         <p:blipFill>
-          <a:blip r:embed="rId2"/>
+          <a:blip r:embed="rId3"/>
           <a:stretch>
             <a:fillRect/>
           </a:stretch>
@@ -9086,7 +9133,7 @@
               </a:spcAft>
             </a:pPr>
             <a:r>
-              <a:rPr b="1" sz="1500">
+              <a:rPr sz="1500" b="1">
                 <a:solidFill>
                   <a:srgbClr val="1B2838"/>
                 </a:solidFill>
@@ -9111,7 +9158,7 @@
               </a:spcAft>
             </a:pPr>
             <a:r>
-              <a:rPr b="1" sz="1500">
+              <a:rPr sz="1500" b="1">
                 <a:solidFill>
                   <a:srgbClr val="1B2838"/>
                 </a:solidFill>
@@ -9136,7 +9183,7 @@
               </a:spcAft>
             </a:pPr>
             <a:r>
-              <a:rPr b="1" sz="1500">
+              <a:rPr sz="1500" b="1">
                 <a:solidFill>
                   <a:srgbClr val="1B2838"/>
                 </a:solidFill>
@@ -9161,7 +9208,7 @@
               </a:spcAft>
             </a:pPr>
             <a:r>
-              <a:rPr b="1" sz="1500">
+              <a:rPr sz="1500" b="1">
                 <a:solidFill>
                   <a:srgbClr val="1B2838"/>
                 </a:solidFill>
@@ -9190,7 +9237,7 @@
 </file>
 
 <file path=ppt/slides/slide7.xml><?xml version="1.0" encoding="utf-8"?>
-<p:sld xmlns:a="http://schemas.openxmlformats.org/drawingml/2006/main" xmlns:p="http://schemas.openxmlformats.org/presentationml/2006/main" xmlns:r="http://schemas.openxmlformats.org/officeDocument/2006/relationships">
+<p:sld xmlns:a="http://schemas.openxmlformats.org/drawingml/2006/main" xmlns:r="http://schemas.openxmlformats.org/officeDocument/2006/relationships" xmlns:p="http://schemas.openxmlformats.org/presentationml/2006/main">
   <p:cSld>
     <p:spTree>
       <p:nvGrpSpPr>
@@ -9198,7 +9245,14 @@
         <p:cNvGrpSpPr/>
         <p:nvPr/>
       </p:nvGrpSpPr>
-      <p:grpSpPr/>
+      <p:grpSpPr>
+        <a:xfrm>
+          <a:off x="0" y="0"/>
+          <a:ext cx="0" cy="0"/>
+          <a:chOff x="0" y="0"/>
+          <a:chExt cx="0" cy="0"/>
+        </a:xfrm>
+      </p:grpSpPr>
       <p:sp>
         <p:nvSpPr>
           <p:cNvPr id="2" name="Rectangle 1"/>
@@ -9240,6 +9294,7 @@
           <a:lstStyle/>
           <a:p>
             <a:pPr algn="ctr"/>
+            <a:endParaRPr/>
           </a:p>
         </p:txBody>
       </p:sp>
@@ -9284,6 +9339,7 @@
           <a:lstStyle/>
           <a:p>
             <a:pPr algn="ctr"/>
+            <a:endParaRPr/>
           </a:p>
         </p:txBody>
       </p:sp>
@@ -9366,7 +9422,7 @@
         <p:spPr>
           <a:xfrm>
             <a:off x="640080" y="1280160"/>
-            <a:ext cx="5760720" cy="4754880"/>
+            <a:ext cx="5760720" cy="2872581"/>
           </a:xfrm>
           <a:prstGeom prst="rect">
             <a:avLst/>
@@ -9385,22 +9441,130 @@
               </a:spcAft>
             </a:pPr>
             <a:r>
-              <a:rPr b="1" sz="1600">
+              <a:rPr sz="1600" b="1" dirty="0">
                 <a:solidFill>
                   <a:srgbClr val="1B2838"/>
                 </a:solidFill>
                 <a:latin typeface="Calibri"/>
               </a:rPr>
-              <a:t>▪ Leë / ontbrekende teks: </a:t>
-            </a:r>
-            <a:r>
-              <a:rPr sz="1600">
-                <a:solidFill>
-                  <a:srgbClr val="1F2A36"/>
-                </a:solidFill>
-                <a:latin typeface="Calibri"/>
-              </a:rPr>
-              <a:t>32 resensies sonder bruikbare teks.</a:t>
+              <a:t>▪ </a:t>
+            </a:r>
+            <a:r>
+              <a:rPr sz="1600" b="1" dirty="0" err="1">
+                <a:solidFill>
+                  <a:srgbClr val="1B2838"/>
+                </a:solidFill>
+                <a:latin typeface="Calibri"/>
+              </a:rPr>
+              <a:t>Leë</a:t>
+            </a:r>
+            <a:r>
+              <a:rPr sz="1600" b="1" dirty="0">
+                <a:solidFill>
+                  <a:srgbClr val="1B2838"/>
+                </a:solidFill>
+                <a:latin typeface="Calibri"/>
+              </a:rPr>
+              <a:t> / </a:t>
+            </a:r>
+            <a:r>
+              <a:rPr sz="1600" b="1" dirty="0" err="1">
+                <a:solidFill>
+                  <a:srgbClr val="1B2838"/>
+                </a:solidFill>
+                <a:latin typeface="Calibri"/>
+              </a:rPr>
+              <a:t>ontbrekende</a:t>
+            </a:r>
+            <a:r>
+              <a:rPr sz="1600" b="1" dirty="0">
+                <a:solidFill>
+                  <a:srgbClr val="1B2838"/>
+                </a:solidFill>
+                <a:latin typeface="Calibri"/>
+              </a:rPr>
+              <a:t> </a:t>
+            </a:r>
+            <a:r>
+              <a:rPr sz="1600" b="1" dirty="0" err="1">
+                <a:solidFill>
+                  <a:srgbClr val="1B2838"/>
+                </a:solidFill>
+                <a:latin typeface="Calibri"/>
+              </a:rPr>
+              <a:t>teks</a:t>
+            </a:r>
+            <a:r>
+              <a:rPr sz="1600" b="1" dirty="0">
+                <a:solidFill>
+                  <a:srgbClr val="1B2838"/>
+                </a:solidFill>
+                <a:latin typeface="Calibri"/>
+              </a:rPr>
+              <a:t>: </a:t>
+            </a:r>
+            <a:r>
+              <a:rPr sz="1600" dirty="0">
+                <a:solidFill>
+                  <a:srgbClr val="1F2A36"/>
+                </a:solidFill>
+                <a:latin typeface="Calibri"/>
+              </a:rPr>
+              <a:t>32 </a:t>
+            </a:r>
+            <a:r>
+              <a:rPr sz="1600" dirty="0" err="1">
+                <a:solidFill>
+                  <a:srgbClr val="1F2A36"/>
+                </a:solidFill>
+                <a:latin typeface="Calibri"/>
+              </a:rPr>
+              <a:t>resensies</a:t>
+            </a:r>
+            <a:r>
+              <a:rPr sz="1600" dirty="0">
+                <a:solidFill>
+                  <a:srgbClr val="1F2A36"/>
+                </a:solidFill>
+                <a:latin typeface="Calibri"/>
+              </a:rPr>
+              <a:t> sonder </a:t>
+            </a:r>
+            <a:r>
+              <a:rPr sz="1600" dirty="0" err="1">
+                <a:solidFill>
+                  <a:srgbClr val="1F2A36"/>
+                </a:solidFill>
+                <a:latin typeface="Calibri"/>
+              </a:rPr>
+              <a:t>bruikbare</a:t>
+            </a:r>
+            <a:r>
+              <a:rPr sz="1600" dirty="0">
+                <a:solidFill>
+                  <a:srgbClr val="1F2A36"/>
+                </a:solidFill>
+                <a:latin typeface="Calibri"/>
+              </a:rPr>
+              <a:t> </a:t>
+            </a:r>
+            <a:r>
+              <a:rPr sz="1600" dirty="0" err="1">
+                <a:solidFill>
+                  <a:srgbClr val="1F2A36"/>
+                </a:solidFill>
+                <a:latin typeface="Calibri"/>
+              </a:rPr>
+              <a:t>teks</a:t>
+            </a:r>
+            <a:r>
+              <a:rPr sz="1600" dirty="0">
+                <a:solidFill>
+                  <a:srgbClr val="1F2A36"/>
+                </a:solidFill>
+                <a:latin typeface="Calibri"/>
+              </a:rPr>
+              <a:t>.</a:t>
             </a:r>
           </a:p>
           <a:p>
@@ -9410,22 +9574,112 @@
               </a:spcAft>
             </a:pPr>
             <a:r>
-              <a:rPr b="1" sz="1600">
+              <a:rPr sz="1600" b="1" dirty="0">
                 <a:solidFill>
                   <a:srgbClr val="1B2838"/>
                 </a:solidFill>
                 <a:latin typeface="Calibri"/>
               </a:rPr>
-              <a:t>▪ Te kort (spam): </a:t>
-            </a:r>
-            <a:r>
-              <a:rPr sz="1600">
-                <a:solidFill>
-                  <a:srgbClr val="1F2A36"/>
-                </a:solidFill>
-                <a:latin typeface="Calibri"/>
-              </a:rPr>
-              <a:t>1 815 resensies korter as 10 karakters (bv. “gg”, “10/10”).</a:t>
+              <a:t>▪ </a:t>
+            </a:r>
+            <a:r>
+              <a:rPr sz="1600" b="1" dirty="0" err="1">
+                <a:solidFill>
+                  <a:srgbClr val="1B2838"/>
+                </a:solidFill>
+                <a:latin typeface="Calibri"/>
+              </a:rPr>
+              <a:t>Te</a:t>
+            </a:r>
+            <a:r>
+              <a:rPr sz="1600" b="1" dirty="0">
+                <a:solidFill>
+                  <a:srgbClr val="1B2838"/>
+                </a:solidFill>
+                <a:latin typeface="Calibri"/>
+              </a:rPr>
+              <a:t> </a:t>
+            </a:r>
+            <a:r>
+              <a:rPr sz="1600" b="1" dirty="0" err="1">
+                <a:solidFill>
+                  <a:srgbClr val="1B2838"/>
+                </a:solidFill>
+                <a:latin typeface="Calibri"/>
+              </a:rPr>
+              <a:t>kort</a:t>
+            </a:r>
+            <a:r>
+              <a:rPr sz="1600" b="1" dirty="0">
+                <a:solidFill>
+                  <a:srgbClr val="1B2838"/>
+                </a:solidFill>
+                <a:latin typeface="Calibri"/>
+              </a:rPr>
+              <a:t> (spam): </a:t>
+            </a:r>
+            <a:r>
+              <a:rPr sz="1600" dirty="0">
+                <a:solidFill>
+                  <a:srgbClr val="1F2A36"/>
+                </a:solidFill>
+                <a:latin typeface="Calibri"/>
+              </a:rPr>
+              <a:t>1 815 </a:t>
+            </a:r>
+            <a:r>
+              <a:rPr sz="1600" dirty="0" err="1">
+                <a:solidFill>
+                  <a:srgbClr val="1F2A36"/>
+                </a:solidFill>
+                <a:latin typeface="Calibri"/>
+              </a:rPr>
+              <a:t>resensies</a:t>
+            </a:r>
+            <a:r>
+              <a:rPr sz="1600" dirty="0">
+                <a:solidFill>
+                  <a:srgbClr val="1F2A36"/>
+                </a:solidFill>
+                <a:latin typeface="Calibri"/>
+              </a:rPr>
+              <a:t> </a:t>
+            </a:r>
+            <a:r>
+              <a:rPr sz="1600" dirty="0" err="1">
+                <a:solidFill>
+                  <a:srgbClr val="1F2A36"/>
+                </a:solidFill>
+                <a:latin typeface="Calibri"/>
+              </a:rPr>
+              <a:t>korter</a:t>
+            </a:r>
+            <a:r>
+              <a:rPr sz="1600" dirty="0">
+                <a:solidFill>
+                  <a:srgbClr val="1F2A36"/>
+                </a:solidFill>
+                <a:latin typeface="Calibri"/>
+              </a:rPr>
+              <a:t> as 10 </a:t>
+            </a:r>
+            <a:r>
+              <a:rPr sz="1600" dirty="0" err="1">
+                <a:solidFill>
+                  <a:srgbClr val="1F2A36"/>
+                </a:solidFill>
+                <a:latin typeface="Calibri"/>
+              </a:rPr>
+              <a:t>karakters</a:t>
+            </a:r>
+            <a:r>
+              <a:rPr sz="1600" dirty="0">
+                <a:solidFill>
+                  <a:srgbClr val="1F2A36"/>
+                </a:solidFill>
+                <a:latin typeface="Calibri"/>
+              </a:rPr>
+              <a:t> (bv. “gg”, “10/10”).</a:t>
             </a:r>
           </a:p>
           <a:p>
@@ -9435,22 +9689,148 @@
               </a:spcAft>
             </a:pPr>
             <a:r>
-              <a:rPr b="1" sz="1600">
+              <a:rPr sz="1600" b="1" dirty="0">
                 <a:solidFill>
                   <a:srgbClr val="1B2838"/>
                 </a:solidFill>
                 <a:latin typeface="Calibri"/>
               </a:rPr>
-              <a:t>▪ Nonsens / emoji-spam: </a:t>
-            </a:r>
-            <a:r>
-              <a:rPr sz="1600">
-                <a:solidFill>
-                  <a:srgbClr val="1F2A36"/>
-                </a:solidFill>
-                <a:latin typeface="Calibri"/>
-              </a:rPr>
-              <a:t>335 resensies waar &gt;50% van karakters nie alfabeties is nie.</a:t>
+              <a:t>▪ </a:t>
+            </a:r>
+            <a:r>
+              <a:rPr sz="1600" b="1" dirty="0" err="1">
+                <a:solidFill>
+                  <a:srgbClr val="1B2838"/>
+                </a:solidFill>
+                <a:latin typeface="Calibri"/>
+              </a:rPr>
+              <a:t>Nonsens</a:t>
+            </a:r>
+            <a:r>
+              <a:rPr sz="1600" b="1" dirty="0">
+                <a:solidFill>
+                  <a:srgbClr val="1B2838"/>
+                </a:solidFill>
+                <a:latin typeface="Calibri"/>
+              </a:rPr>
+              <a:t> / emoji-spam: </a:t>
+            </a:r>
+            <a:r>
+              <a:rPr sz="1600" dirty="0">
+                <a:solidFill>
+                  <a:srgbClr val="1F2A36"/>
+                </a:solidFill>
+                <a:latin typeface="Calibri"/>
+              </a:rPr>
+              <a:t>335 </a:t>
+            </a:r>
+            <a:r>
+              <a:rPr sz="1600" dirty="0" err="1">
+                <a:solidFill>
+                  <a:srgbClr val="1F2A36"/>
+                </a:solidFill>
+                <a:latin typeface="Calibri"/>
+              </a:rPr>
+              <a:t>resensies</a:t>
+            </a:r>
+            <a:r>
+              <a:rPr sz="1600" dirty="0">
+                <a:solidFill>
+                  <a:srgbClr val="1F2A36"/>
+                </a:solidFill>
+                <a:latin typeface="Calibri"/>
+              </a:rPr>
+              <a:t> </a:t>
+            </a:r>
+            <a:r>
+              <a:rPr sz="1600" dirty="0" err="1">
+                <a:solidFill>
+                  <a:srgbClr val="1F2A36"/>
+                </a:solidFill>
+                <a:latin typeface="Calibri"/>
+              </a:rPr>
+              <a:t>waar</a:t>
+            </a:r>
+            <a:r>
+              <a:rPr sz="1600" dirty="0">
+                <a:solidFill>
+                  <a:srgbClr val="1F2A36"/>
+                </a:solidFill>
+                <a:latin typeface="Calibri"/>
+              </a:rPr>
+              <a:t> &gt;50% van </a:t>
+            </a:r>
+            <a:r>
+              <a:rPr sz="1600" dirty="0" err="1">
+                <a:solidFill>
+                  <a:srgbClr val="1F2A36"/>
+                </a:solidFill>
+                <a:latin typeface="Calibri"/>
+              </a:rPr>
+              <a:t>karakters</a:t>
+            </a:r>
+            <a:r>
+              <a:rPr sz="1600" dirty="0">
+                <a:solidFill>
+                  <a:srgbClr val="1F2A36"/>
+                </a:solidFill>
+                <a:latin typeface="Calibri"/>
+              </a:rPr>
+              <a:t> </a:t>
+            </a:r>
+            <a:r>
+              <a:rPr sz="1600" dirty="0" err="1">
+                <a:solidFill>
+                  <a:srgbClr val="1F2A36"/>
+                </a:solidFill>
+                <a:latin typeface="Calibri"/>
+              </a:rPr>
+              <a:t>nie</a:t>
+            </a:r>
+            <a:r>
+              <a:rPr sz="1600" dirty="0">
+                <a:solidFill>
+                  <a:srgbClr val="1F2A36"/>
+                </a:solidFill>
+                <a:latin typeface="Calibri"/>
+              </a:rPr>
+              <a:t> </a:t>
+            </a:r>
+            <a:r>
+              <a:rPr sz="1600" dirty="0" err="1">
+                <a:solidFill>
+                  <a:srgbClr val="1F2A36"/>
+                </a:solidFill>
+                <a:latin typeface="Calibri"/>
+              </a:rPr>
+              <a:t>alfabeties</a:t>
+            </a:r>
+            <a:r>
+              <a:rPr sz="1600" dirty="0">
+                <a:solidFill>
+                  <a:srgbClr val="1F2A36"/>
+                </a:solidFill>
+                <a:latin typeface="Calibri"/>
+              </a:rPr>
+              <a:t> is </a:t>
+            </a:r>
+            <a:r>
+              <a:rPr sz="1600" dirty="0" err="1">
+                <a:solidFill>
+                  <a:srgbClr val="1F2A36"/>
+                </a:solidFill>
+                <a:latin typeface="Calibri"/>
+              </a:rPr>
+              <a:t>nie</a:t>
+            </a:r>
+            <a:r>
+              <a:rPr sz="1600" dirty="0">
+                <a:solidFill>
+                  <a:srgbClr val="1F2A36"/>
+                </a:solidFill>
+                <a:latin typeface="Calibri"/>
+              </a:rPr>
+              <a:t>.</a:t>
             </a:r>
           </a:p>
           <a:p>
@@ -9460,22 +9840,85 @@
               </a:spcAft>
             </a:pPr>
             <a:r>
-              <a:rPr b="1" sz="1600">
+              <a:rPr sz="1600" b="1" dirty="0">
                 <a:solidFill>
                   <a:srgbClr val="1B2838"/>
                 </a:solidFill>
                 <a:latin typeface="Calibri"/>
               </a:rPr>
-              <a:t>▪ Speeltyd-uitskieters: </a:t>
-            </a:r>
-            <a:r>
-              <a:rPr sz="1600">
-                <a:solidFill>
-                  <a:srgbClr val="1F2A36"/>
-                </a:solidFill>
-                <a:latin typeface="Calibri"/>
-              </a:rPr>
-              <a:t>maksimum 3 288 515 minute (~6 jaar) — onrealisties vir die venster.</a:t>
+              <a:t>▪ 30 </a:t>
+            </a:r>
+            <a:r>
+              <a:rPr sz="1600" b="1" dirty="0" err="1">
+                <a:solidFill>
+                  <a:srgbClr val="1B2838"/>
+                </a:solidFill>
+                <a:latin typeface="Calibri"/>
+              </a:rPr>
+              <a:t>verskillende</a:t>
+            </a:r>
+            <a:r>
+              <a:rPr sz="1600" b="1" dirty="0">
+                <a:solidFill>
+                  <a:srgbClr val="1B2838"/>
+                </a:solidFill>
+                <a:latin typeface="Calibri"/>
+              </a:rPr>
+              <a:t> tale: </a:t>
+            </a:r>
+            <a:r>
+              <a:rPr sz="1600" dirty="0" err="1">
+                <a:solidFill>
+                  <a:srgbClr val="1F2A36"/>
+                </a:solidFill>
+                <a:latin typeface="Calibri"/>
+              </a:rPr>
+              <a:t>gemengde</a:t>
+            </a:r>
+            <a:r>
+              <a:rPr sz="1600" dirty="0">
+                <a:solidFill>
+                  <a:srgbClr val="1F2A36"/>
+                </a:solidFill>
+                <a:latin typeface="Calibri"/>
+              </a:rPr>
+              <a:t> </a:t>
+            </a:r>
+            <a:r>
+              <a:rPr sz="1600" dirty="0" err="1">
+                <a:solidFill>
+                  <a:srgbClr val="1F2A36"/>
+                </a:solidFill>
+                <a:latin typeface="Calibri"/>
+              </a:rPr>
+              <a:t>taaldata</a:t>
+            </a:r>
+            <a:r>
+              <a:rPr sz="1600" dirty="0">
+                <a:solidFill>
+                  <a:srgbClr val="1F2A36"/>
+                </a:solidFill>
+                <a:latin typeface="Calibri"/>
+              </a:rPr>
+              <a:t>; NLP-filter later </a:t>
+            </a:r>
+            <a:r>
+              <a:rPr sz="1600" dirty="0" err="1">
+                <a:solidFill>
+                  <a:srgbClr val="1F2A36"/>
+                </a:solidFill>
+                <a:latin typeface="Calibri"/>
+              </a:rPr>
+              <a:t>na</a:t>
+            </a:r>
+            <a:r>
+              <a:rPr sz="1600" dirty="0">
+                <a:solidFill>
+                  <a:srgbClr val="1F2A36"/>
+                </a:solidFill>
+                <a:latin typeface="Calibri"/>
+              </a:rPr>
+              <a:t> Engels.</a:t>
             </a:r>
           </a:p>
           <a:p>
@@ -9485,47 +9928,148 @@
               </a:spcAft>
             </a:pPr>
             <a:r>
-              <a:rPr b="1" sz="1600">
+              <a:rPr sz="1600" b="1" dirty="0">
                 <a:solidFill>
                   <a:srgbClr val="1B2838"/>
                 </a:solidFill>
                 <a:latin typeface="Calibri"/>
               </a:rPr>
-              <a:t>▪ 30 verskillende tale: </a:t>
-            </a:r>
-            <a:r>
-              <a:rPr sz="1600">
-                <a:solidFill>
-                  <a:srgbClr val="1F2A36"/>
-                </a:solidFill>
-                <a:latin typeface="Calibri"/>
-              </a:rPr>
-              <a:t>gemengde taaldata; NLP-filter later na Engels.</a:t>
-            </a:r>
-          </a:p>
-          <a:p>
-            <a:pPr>
-              <a:spcAft>
-                <a:spcPts val="1100"/>
-              </a:spcAft>
-            </a:pPr>
-            <a:r>
-              <a:rPr b="1" sz="1600">
+              <a:t>▪ </a:t>
+            </a:r>
+            <a:r>
+              <a:rPr sz="1600" b="1" dirty="0" err="1">
                 <a:solidFill>
                   <a:srgbClr val="1B2838"/>
                 </a:solidFill>
                 <a:latin typeface="Calibri"/>
               </a:rPr>
-              <a:t>▪ Tydstempels: </a:t>
-            </a:r>
-            <a:r>
-              <a:rPr sz="1600">
-                <a:solidFill>
-                  <a:srgbClr val="1F2A36"/>
-                </a:solidFill>
-                <a:latin typeface="Calibri"/>
-              </a:rPr>
-              <a:t>Unix-tydstempels — nie mensleesbaar nie; afgeleide datums nodig.</a:t>
+              <a:t>Tydstempels</a:t>
+            </a:r>
+            <a:r>
+              <a:rPr sz="1600" b="1" dirty="0">
+                <a:solidFill>
+                  <a:srgbClr val="1B2838"/>
+                </a:solidFill>
+                <a:latin typeface="Calibri"/>
+              </a:rPr>
+              <a:t>: </a:t>
+            </a:r>
+            <a:r>
+              <a:rPr sz="1600" dirty="0">
+                <a:solidFill>
+                  <a:srgbClr val="1F2A36"/>
+                </a:solidFill>
+                <a:latin typeface="Calibri"/>
+              </a:rPr>
+              <a:t>Unix-</a:t>
+            </a:r>
+            <a:r>
+              <a:rPr sz="1600" dirty="0" err="1">
+                <a:solidFill>
+                  <a:srgbClr val="1F2A36"/>
+                </a:solidFill>
+                <a:latin typeface="Calibri"/>
+              </a:rPr>
+              <a:t>tydstempels</a:t>
+            </a:r>
+            <a:r>
+              <a:rPr sz="1600" dirty="0">
+                <a:solidFill>
+                  <a:srgbClr val="1F2A36"/>
+                </a:solidFill>
+                <a:latin typeface="Calibri"/>
+              </a:rPr>
+              <a:t> — </a:t>
+            </a:r>
+            <a:r>
+              <a:rPr sz="1600" dirty="0" err="1">
+                <a:solidFill>
+                  <a:srgbClr val="1F2A36"/>
+                </a:solidFill>
+                <a:latin typeface="Calibri"/>
+              </a:rPr>
+              <a:t>nie</a:t>
+            </a:r>
+            <a:r>
+              <a:rPr sz="1600" dirty="0">
+                <a:solidFill>
+                  <a:srgbClr val="1F2A36"/>
+                </a:solidFill>
+                <a:latin typeface="Calibri"/>
+              </a:rPr>
+              <a:t> </a:t>
+            </a:r>
+            <a:r>
+              <a:rPr sz="1600" dirty="0" err="1">
+                <a:solidFill>
+                  <a:srgbClr val="1F2A36"/>
+                </a:solidFill>
+                <a:latin typeface="Calibri"/>
+              </a:rPr>
+              <a:t>mensleesbaar</a:t>
+            </a:r>
+            <a:r>
+              <a:rPr sz="1600" dirty="0">
+                <a:solidFill>
+                  <a:srgbClr val="1F2A36"/>
+                </a:solidFill>
+                <a:latin typeface="Calibri"/>
+              </a:rPr>
+              <a:t> </a:t>
+            </a:r>
+            <a:r>
+              <a:rPr sz="1600" dirty="0" err="1">
+                <a:solidFill>
+                  <a:srgbClr val="1F2A36"/>
+                </a:solidFill>
+                <a:latin typeface="Calibri"/>
+              </a:rPr>
+              <a:t>nie</a:t>
+            </a:r>
+            <a:r>
+              <a:rPr sz="1600" dirty="0">
+                <a:solidFill>
+                  <a:srgbClr val="1F2A36"/>
+                </a:solidFill>
+                <a:latin typeface="Calibri"/>
+              </a:rPr>
+              <a:t>; </a:t>
+            </a:r>
+            <a:r>
+              <a:rPr sz="1600" dirty="0" err="1">
+                <a:solidFill>
+                  <a:srgbClr val="1F2A36"/>
+                </a:solidFill>
+                <a:latin typeface="Calibri"/>
+              </a:rPr>
+              <a:t>afgeleide</a:t>
+            </a:r>
+            <a:r>
+              <a:rPr sz="1600" dirty="0">
+                <a:solidFill>
+                  <a:srgbClr val="1F2A36"/>
+                </a:solidFill>
+                <a:latin typeface="Calibri"/>
+              </a:rPr>
+              <a:t> datums </a:t>
+            </a:r>
+            <a:r>
+              <a:rPr sz="1600" dirty="0" err="1">
+                <a:solidFill>
+                  <a:srgbClr val="1F2A36"/>
+                </a:solidFill>
+                <a:latin typeface="Calibri"/>
+              </a:rPr>
+              <a:t>nodig</a:t>
+            </a:r>
+            <a:r>
+              <a:rPr sz="1600" dirty="0">
+                <a:solidFill>
+                  <a:srgbClr val="1F2A36"/>
+                </a:solidFill>
+                <a:latin typeface="Calibri"/>
+              </a:rPr>
+              <a:t>.</a:t>
             </a:r>
           </a:p>
         </p:txBody>
@@ -9571,6 +10115,7 @@
           <a:lstStyle/>
           <a:p>
             <a:pPr algn="ctr"/>
+            <a:endParaRPr/>
           </a:p>
         </p:txBody>
       </p:sp>
@@ -9650,6 +10195,7 @@
           <a:lstStyle/>
           <a:p>
             <a:pPr algn="ctr"/>
+            <a:endParaRPr/>
           </a:p>
         </p:txBody>
       </p:sp>
@@ -9764,6 +10310,7 @@
           <a:lstStyle/>
           <a:p>
             <a:pPr algn="ctr"/>
+            <a:endParaRPr/>
           </a:p>
         </p:txBody>
       </p:sp>
@@ -9878,6 +10425,7 @@
           <a:lstStyle/>
           <a:p>
             <a:pPr algn="ctr"/>
+            <a:endParaRPr/>
           </a:p>
         </p:txBody>
       </p:sp>
@@ -9992,6 +10540,7 @@
           <a:lstStyle/>
           <a:p>
             <a:pPr algn="ctr"/>
+            <a:endParaRPr/>
           </a:p>
         </p:txBody>
       </p:sp>
@@ -10074,7 +10623,7 @@
 </file>
 
 <file path=ppt/slides/slide8.xml><?xml version="1.0" encoding="utf-8"?>
-<p:sld xmlns:a="http://schemas.openxmlformats.org/drawingml/2006/main" xmlns:p="http://schemas.openxmlformats.org/presentationml/2006/main" xmlns:r="http://schemas.openxmlformats.org/officeDocument/2006/relationships">
+<p:sld xmlns:a="http://schemas.openxmlformats.org/drawingml/2006/main" xmlns:r="http://schemas.openxmlformats.org/officeDocument/2006/relationships" xmlns:p="http://schemas.openxmlformats.org/presentationml/2006/main">
   <p:cSld>
     <p:spTree>
       <p:nvGrpSpPr>
@@ -10082,7 +10631,14 @@
         <p:cNvGrpSpPr/>
         <p:nvPr/>
       </p:nvGrpSpPr>
-      <p:grpSpPr/>
+      <p:grpSpPr>
+        <a:xfrm>
+          <a:off x="0" y="0"/>
+          <a:ext cx="0" cy="0"/>
+          <a:chOff x="0" y="0"/>
+          <a:chExt cx="0" cy="0"/>
+        </a:xfrm>
+      </p:grpSpPr>
       <p:sp>
         <p:nvSpPr>
           <p:cNvPr id="2" name="Rectangle 1"/>
@@ -10124,6 +10680,7 @@
           <a:lstStyle/>
           <a:p>
             <a:pPr algn="ctr"/>
+            <a:endParaRPr/>
           </a:p>
         </p:txBody>
       </p:sp>
@@ -10168,6 +10725,7 @@
           <a:lstStyle/>
           <a:p>
             <a:pPr algn="ctr"/>
+            <a:endParaRPr/>
           </a:p>
         </p:txBody>
       </p:sp>
@@ -10282,6 +10840,7 @@
           <a:lstStyle/>
           <a:p>
             <a:pPr algn="ctr"/>
+            <a:endParaRPr/>
           </a:p>
         </p:txBody>
       </p:sp>
@@ -10361,6 +10920,7 @@
           <a:lstStyle/>
           <a:p>
             <a:pPr algn="ctr"/>
+            <a:endParaRPr/>
           </a:p>
         </p:txBody>
       </p:sp>
@@ -10440,6 +11000,7 @@
           <a:lstStyle/>
           <a:p>
             <a:pPr algn="ctr"/>
+            <a:endParaRPr/>
           </a:p>
         </p:txBody>
       </p:sp>
@@ -10519,6 +11080,7 @@
           <a:lstStyle/>
           <a:p>
             <a:pPr algn="ctr"/>
+            <a:endParaRPr/>
           </a:p>
         </p:txBody>
       </p:sp>
@@ -10598,6 +11160,7 @@
           <a:lstStyle/>
           <a:p>
             <a:pPr algn="ctr"/>
+            <a:endParaRPr/>
           </a:p>
         </p:txBody>
       </p:sp>
@@ -10677,6 +11240,7 @@
           <a:lstStyle/>
           <a:p>
             <a:pPr algn="ctr"/>
+            <a:endParaRPr/>
           </a:p>
         </p:txBody>
       </p:sp>
@@ -10756,6 +11320,7 @@
           <a:lstStyle/>
           <a:p>
             <a:pPr algn="ctr"/>
+            <a:endParaRPr/>
           </a:p>
         </p:txBody>
       </p:sp>
@@ -10835,6 +11400,7 @@
           <a:lstStyle/>
           <a:p>
             <a:pPr algn="ctr"/>
+            <a:endParaRPr/>
           </a:p>
         </p:txBody>
       </p:sp>
@@ -10914,6 +11480,7 @@
           <a:lstStyle/>
           <a:p>
             <a:pPr algn="ctr"/>
+            <a:endParaRPr/>
           </a:p>
         </p:txBody>
       </p:sp>
@@ -10993,6 +11560,7 @@
           <a:lstStyle/>
           <a:p>
             <a:pPr algn="ctr"/>
+            <a:endParaRPr/>
           </a:p>
         </p:txBody>
       </p:sp>
@@ -11072,6 +11640,7 @@
           <a:lstStyle/>
           <a:p>
             <a:pPr algn="ctr"/>
+            <a:endParaRPr/>
           </a:p>
         </p:txBody>
       </p:sp>
@@ -11151,6 +11720,7 @@
           <a:lstStyle/>
           <a:p>
             <a:pPr algn="ctr"/>
+            <a:endParaRPr/>
           </a:p>
         </p:txBody>
       </p:sp>
@@ -11230,6 +11800,7 @@
           <a:lstStyle/>
           <a:p>
             <a:pPr algn="ctr"/>
+            <a:endParaRPr/>
           </a:p>
         </p:txBody>
       </p:sp>
@@ -11309,6 +11880,7 @@
           <a:lstStyle/>
           <a:p>
             <a:pPr algn="ctr"/>
+            <a:endParaRPr/>
           </a:p>
         </p:txBody>
       </p:sp>
@@ -11388,6 +11960,7 @@
           <a:lstStyle/>
           <a:p>
             <a:pPr algn="ctr"/>
+            <a:endParaRPr/>
           </a:p>
         </p:txBody>
       </p:sp>
@@ -11467,6 +12040,7 @@
           <a:lstStyle/>
           <a:p>
             <a:pPr algn="ctr"/>
+            <a:endParaRPr/>
           </a:p>
         </p:txBody>
       </p:sp>
@@ -11546,6 +12120,7 @@
           <a:lstStyle/>
           <a:p>
             <a:pPr algn="ctr"/>
+            <a:endParaRPr/>
           </a:p>
         </p:txBody>
       </p:sp>
@@ -11625,6 +12200,7 @@
           <a:lstStyle/>
           <a:p>
             <a:pPr algn="ctr"/>
+            <a:endParaRPr/>
           </a:p>
         </p:txBody>
       </p:sp>
@@ -11704,6 +12280,7 @@
           <a:lstStyle/>
           <a:p>
             <a:pPr algn="ctr"/>
+            <a:endParaRPr/>
           </a:p>
         </p:txBody>
       </p:sp>
@@ -11783,6 +12360,7 @@
           <a:lstStyle/>
           <a:p>
             <a:pPr algn="ctr"/>
+            <a:endParaRPr/>
           </a:p>
         </p:txBody>
       </p:sp>
@@ -11862,6 +12440,7 @@
           <a:lstStyle/>
           <a:p>
             <a:pPr algn="ctr"/>
+            <a:endParaRPr/>
           </a:p>
         </p:txBody>
       </p:sp>
@@ -11941,6 +12520,7 @@
           <a:lstStyle/>
           <a:p>
             <a:pPr algn="ctr"/>
+            <a:endParaRPr/>
           </a:p>
         </p:txBody>
       </p:sp>
@@ -12020,6 +12600,7 @@
           <a:lstStyle/>
           <a:p>
             <a:pPr algn="ctr"/>
+            <a:endParaRPr/>
           </a:p>
         </p:txBody>
       </p:sp>
@@ -12099,6 +12680,7 @@
           <a:lstStyle/>
           <a:p>
             <a:pPr algn="ctr"/>
+            <a:endParaRPr/>
           </a:p>
         </p:txBody>
       </p:sp>
@@ -12146,7 +12728,7 @@
 </file>
 
 <file path=ppt/slides/slide9.xml><?xml version="1.0" encoding="utf-8"?>
-<p:sld xmlns:a="http://schemas.openxmlformats.org/drawingml/2006/main" xmlns:p="http://schemas.openxmlformats.org/presentationml/2006/main" xmlns:r="http://schemas.openxmlformats.org/officeDocument/2006/relationships">
+<p:sld xmlns:a="http://schemas.openxmlformats.org/drawingml/2006/main" xmlns:r="http://schemas.openxmlformats.org/officeDocument/2006/relationships" xmlns:p="http://schemas.openxmlformats.org/presentationml/2006/main">
   <p:cSld>
     <p:spTree>
       <p:nvGrpSpPr>
@@ -12154,7 +12736,14 @@
         <p:cNvGrpSpPr/>
         <p:nvPr/>
       </p:nvGrpSpPr>
-      <p:grpSpPr/>
+      <p:grpSpPr>
+        <a:xfrm>
+          <a:off x="0" y="0"/>
+          <a:ext cx="0" cy="0"/>
+          <a:chOff x="0" y="0"/>
+          <a:chExt cx="0" cy="0"/>
+        </a:xfrm>
+      </p:grpSpPr>
       <p:sp>
         <p:nvSpPr>
           <p:cNvPr id="2" name="Rectangle 1"/>
@@ -12196,6 +12785,7 @@
           <a:lstStyle/>
           <a:p>
             <a:pPr algn="ctr"/>
+            <a:endParaRPr/>
           </a:p>
         </p:txBody>
       </p:sp>
@@ -12240,6 +12830,7 @@
           <a:lstStyle/>
           <a:p>
             <a:pPr algn="ctr"/>
+            <a:endParaRPr/>
           </a:p>
         </p:txBody>
       </p:sp>
@@ -12322,7 +12913,7 @@
           <p:nvPr/>
         </p:nvPicPr>
         <p:blipFill>
-          <a:blip r:embed="rId2"/>
+          <a:blip r:embed="rId3"/>
           <a:stretch>
             <a:fillRect/>
           </a:stretch>
@@ -12365,7 +12956,7 @@
               </a:spcAft>
             </a:pPr>
             <a:r>
-              <a:rPr b="1" sz="1500">
+              <a:rPr sz="1500" b="1" dirty="0">
                 <a:solidFill>
                   <a:srgbClr val="1B2838"/>
                 </a:solidFill>
@@ -12374,13 +12965,49 @@
               <a:t>▪ 161 630 → 159 768: </a:t>
             </a:r>
             <a:r>
-              <a:rPr sz="1500">
-                <a:solidFill>
-                  <a:srgbClr val="1F2A36"/>
-                </a:solidFill>
-                <a:latin typeface="Calibri"/>
-              </a:rPr>
-              <a:t>1 862 resensies verwyder (1.2%).</a:t>
+              <a:rPr sz="1500" dirty="0">
+                <a:solidFill>
+                  <a:srgbClr val="1F2A36"/>
+                </a:solidFill>
+                <a:latin typeface="Calibri"/>
+              </a:rPr>
+              <a:t>1 862 </a:t>
+            </a:r>
+            <a:r>
+              <a:rPr sz="1500" dirty="0" err="1">
+                <a:solidFill>
+                  <a:srgbClr val="1F2A36"/>
+                </a:solidFill>
+                <a:latin typeface="Calibri"/>
+              </a:rPr>
+              <a:t>resensies</a:t>
+            </a:r>
+            <a:r>
+              <a:rPr sz="1500" dirty="0">
+                <a:solidFill>
+                  <a:srgbClr val="1F2A36"/>
+                </a:solidFill>
+                <a:latin typeface="Calibri"/>
+              </a:rPr>
+              <a:t> </a:t>
+            </a:r>
+            <a:r>
+              <a:rPr sz="1500" dirty="0" err="1">
+                <a:solidFill>
+                  <a:srgbClr val="1F2A36"/>
+                </a:solidFill>
+                <a:latin typeface="Calibri"/>
+              </a:rPr>
+              <a:t>verwyder</a:t>
+            </a:r>
+            <a:r>
+              <a:rPr sz="1500" dirty="0">
+                <a:solidFill>
+                  <a:srgbClr val="1F2A36"/>
+                </a:solidFill>
+                <a:latin typeface="Calibri"/>
+              </a:rPr>
+              <a:t> (1.2%).</a:t>
             </a:r>
           </a:p>
           <a:p>
@@ -12390,22 +13017,139 @@
               </a:spcAft>
             </a:pPr>
             <a:r>
-              <a:rPr b="1" sz="1500">
+              <a:rPr sz="1500" b="1" dirty="0">
                 <a:solidFill>
                   <a:srgbClr val="1B2838"/>
                 </a:solidFill>
                 <a:latin typeface="Calibri"/>
               </a:rPr>
-              <a:t>▪ Nie verwyder nie: </a:t>
-            </a:r>
-            <a:r>
-              <a:rPr sz="1500">
-                <a:solidFill>
-                  <a:srgbClr val="1F2A36"/>
-                </a:solidFill>
-                <a:latin typeface="Calibri"/>
-              </a:rPr>
-              <a:t>uitskieters word afgekap, nie geskrap nie.</a:t>
+              <a:t>▪ Nie </a:t>
+            </a:r>
+            <a:r>
+              <a:rPr sz="1500" b="1" dirty="0" err="1">
+                <a:solidFill>
+                  <a:srgbClr val="1B2838"/>
+                </a:solidFill>
+                <a:latin typeface="Calibri"/>
+              </a:rPr>
+              <a:t>verwyder</a:t>
+            </a:r>
+            <a:r>
+              <a:rPr sz="1500" b="1" dirty="0">
+                <a:solidFill>
+                  <a:srgbClr val="1B2838"/>
+                </a:solidFill>
+                <a:latin typeface="Calibri"/>
+              </a:rPr>
+              <a:t> </a:t>
+            </a:r>
+            <a:r>
+              <a:rPr sz="1500" b="1" dirty="0" err="1">
+                <a:solidFill>
+                  <a:srgbClr val="1B2838"/>
+                </a:solidFill>
+                <a:latin typeface="Calibri"/>
+              </a:rPr>
+              <a:t>nie</a:t>
+            </a:r>
+            <a:r>
+              <a:rPr sz="1500" b="1" dirty="0">
+                <a:solidFill>
+                  <a:srgbClr val="1B2838"/>
+                </a:solidFill>
+                <a:latin typeface="Calibri"/>
+              </a:rPr>
+              <a:t>: </a:t>
+            </a:r>
+            <a:r>
+              <a:rPr sz="1500" dirty="0" err="1">
+                <a:solidFill>
+                  <a:srgbClr val="1F2A36"/>
+                </a:solidFill>
+                <a:latin typeface="Calibri"/>
+              </a:rPr>
+              <a:t>uitskieters</a:t>
+            </a:r>
+            <a:r>
+              <a:rPr sz="1500" dirty="0">
+                <a:solidFill>
+                  <a:srgbClr val="1F2A36"/>
+                </a:solidFill>
+                <a:latin typeface="Calibri"/>
+              </a:rPr>
+              <a:t> word </a:t>
+            </a:r>
+            <a:r>
+              <a:rPr sz="1500" dirty="0" err="1">
+                <a:solidFill>
+                  <a:srgbClr val="1F2A36"/>
+                </a:solidFill>
+                <a:latin typeface="Calibri"/>
+              </a:rPr>
+              <a:t>afgekap</a:t>
+            </a:r>
+            <a:r>
+              <a:rPr sz="1500" dirty="0">
+                <a:solidFill>
+                  <a:srgbClr val="1F2A36"/>
+                </a:solidFill>
+                <a:latin typeface="Calibri"/>
+              </a:rPr>
+              <a:t>, </a:t>
+            </a:r>
+            <a:r>
+              <a:rPr sz="1500" dirty="0" err="1">
+                <a:solidFill>
+                  <a:srgbClr val="1F2A36"/>
+                </a:solidFill>
+                <a:latin typeface="Calibri"/>
+              </a:rPr>
+              <a:t>nie</a:t>
+            </a:r>
+            <a:r>
+              <a:rPr sz="1500" dirty="0">
+                <a:solidFill>
+                  <a:srgbClr val="1F2A36"/>
+                </a:solidFill>
+                <a:latin typeface="Calibri"/>
+              </a:rPr>
+              <a:t> </a:t>
+            </a:r>
+            <a:r>
+              <a:rPr sz="1500" dirty="0" err="1">
+                <a:solidFill>
+                  <a:srgbClr val="1F2A36"/>
+                </a:solidFill>
+                <a:latin typeface="Calibri"/>
+              </a:rPr>
+              <a:t>geskrap</a:t>
+            </a:r>
+            <a:r>
+              <a:rPr sz="1500" dirty="0">
+                <a:solidFill>
+                  <a:srgbClr val="1F2A36"/>
+                </a:solidFill>
+                <a:latin typeface="Calibri"/>
+              </a:rPr>
+              <a:t> </a:t>
+            </a:r>
+            <a:r>
+              <a:rPr sz="1500" dirty="0" err="1">
+                <a:solidFill>
+                  <a:srgbClr val="1F2A36"/>
+                </a:solidFill>
+                <a:latin typeface="Calibri"/>
+              </a:rPr>
+              <a:t>nie</a:t>
+            </a:r>
+            <a:r>
+              <a:rPr sz="1500" dirty="0">
+                <a:solidFill>
+                  <a:srgbClr val="1F2A36"/>
+                </a:solidFill>
+                <a:latin typeface="Calibri"/>
+              </a:rPr>
+              <a:t>.</a:t>
             </a:r>
           </a:p>
           <a:p>
@@ -12415,23 +13159,128 @@
               </a:spcAft>
             </a:pPr>
             <a:r>
-              <a:rPr b="1" sz="1500">
+              <a:rPr sz="1500" b="1" dirty="0">
                 <a:solidFill>
                   <a:srgbClr val="1B2838"/>
                 </a:solidFill>
                 <a:latin typeface="Calibri"/>
               </a:rPr>
-              <a:t>▪ Herhaalbaar: </a:t>
-            </a:r>
-            <a:r>
-              <a:rPr sz="1500">
-                <a:solidFill>
-                  <a:srgbClr val="1F2A36"/>
-                </a:solidFill>
-                <a:latin typeface="Calibri"/>
-              </a:rPr>
-              <a:t>process_reviews() kan die hele pyplyn weer hardloop.</a:t>
-            </a:r>
+              <a:t>▪ </a:t>
+            </a:r>
+            <a:r>
+              <a:rPr sz="1500" b="1" dirty="0" err="1">
+                <a:solidFill>
+                  <a:srgbClr val="1B2838"/>
+                </a:solidFill>
+                <a:latin typeface="Calibri"/>
+              </a:rPr>
+              <a:t>Herhaalbaar</a:t>
+            </a:r>
+            <a:r>
+              <a:rPr sz="1500" b="1" dirty="0">
+                <a:solidFill>
+                  <a:srgbClr val="1B2838"/>
+                </a:solidFill>
+                <a:latin typeface="Calibri"/>
+              </a:rPr>
+              <a:t>: </a:t>
+            </a:r>
+            <a:r>
+              <a:rPr sz="1500" dirty="0" err="1">
+                <a:solidFill>
+                  <a:srgbClr val="1F2A36"/>
+                </a:solidFill>
+                <a:latin typeface="Calibri"/>
+              </a:rPr>
+              <a:t>process_reviews</a:t>
+            </a:r>
+            <a:r>
+              <a:rPr sz="1500" dirty="0">
+                <a:solidFill>
+                  <a:srgbClr val="1F2A36"/>
+                </a:solidFill>
+                <a:latin typeface="Calibri"/>
+              </a:rPr>
+              <a:t>() </a:t>
+            </a:r>
+            <a:r>
+              <a:rPr sz="1500" dirty="0" err="1">
+                <a:solidFill>
+                  <a:srgbClr val="1F2A36"/>
+                </a:solidFill>
+                <a:latin typeface="Calibri"/>
+              </a:rPr>
+              <a:t>kan</a:t>
+            </a:r>
+            <a:r>
+              <a:rPr sz="1500" dirty="0">
+                <a:solidFill>
+                  <a:srgbClr val="1F2A36"/>
+                </a:solidFill>
+                <a:latin typeface="Calibri"/>
+              </a:rPr>
+              <a:t> die hele </a:t>
+            </a:r>
+            <a:r>
+              <a:rPr sz="1500" dirty="0" err="1">
+                <a:solidFill>
+                  <a:srgbClr val="1F2A36"/>
+                </a:solidFill>
+                <a:latin typeface="Calibri"/>
+              </a:rPr>
+              <a:t>pyplyn</a:t>
+            </a:r>
+            <a:r>
+              <a:rPr sz="1500" dirty="0">
+                <a:solidFill>
+                  <a:srgbClr val="1F2A36"/>
+                </a:solidFill>
+                <a:latin typeface="Calibri"/>
+              </a:rPr>
+              <a:t> </a:t>
+            </a:r>
+            <a:r>
+              <a:rPr sz="1500" dirty="0" err="1">
+                <a:solidFill>
+                  <a:srgbClr val="1F2A36"/>
+                </a:solidFill>
+                <a:latin typeface="Calibri"/>
+              </a:rPr>
+              <a:t>weer</a:t>
+            </a:r>
+            <a:r>
+              <a:rPr sz="1500" dirty="0">
+                <a:solidFill>
+                  <a:srgbClr val="1F2A36"/>
+                </a:solidFill>
+                <a:latin typeface="Calibri"/>
+              </a:rPr>
+              <a:t> </a:t>
+            </a:r>
+            <a:r>
+              <a:rPr sz="1500" dirty="0" err="1">
+                <a:solidFill>
+                  <a:srgbClr val="1F2A36"/>
+                </a:solidFill>
+                <a:latin typeface="Calibri"/>
+              </a:rPr>
+              <a:t>hardloop</a:t>
+            </a:r>
+            <a:r>
+              <a:rPr sz="1500" dirty="0">
+                <a:solidFill>
+                  <a:srgbClr val="1F2A36"/>
+                </a:solidFill>
+                <a:latin typeface="Calibri"/>
+              </a:rPr>
+              <a:t>.</a:t>
+            </a:r>
+            <a:endParaRPr lang="en-US" sz="1500" dirty="0">
+              <a:solidFill>
+                <a:srgbClr val="1F2A36"/>
+              </a:solidFill>
+              <a:latin typeface="Calibri"/>
+            </a:endParaRPr>
           </a:p>
           <a:p>
             <a:pPr>
@@ -12440,7 +13289,7 @@
               </a:spcAft>
             </a:pPr>
             <a:r>
-              <a:rPr b="1" sz="1500">
+              <a:rPr lang="nl-NL" sz="1500" b="1" dirty="0">
                 <a:solidFill>
                   <a:srgbClr val="1B2838"/>
                 </a:solidFill>
@@ -12449,7 +13298,7 @@
               <a:t>▪ Bewaring: </a:t>
             </a:r>
             <a:r>
-              <a:rPr sz="1500">
+              <a:rPr lang="nl-NL" sz="1500" dirty="0">
                 <a:solidFill>
                   <a:srgbClr val="1F2A36"/>
                 </a:solidFill>
@@ -12799,44 +13648,44 @@
         <a:sysClr val="window" lastClr="FFFFFF"/>
       </a:lt1>
       <a:dk2>
-        <a:srgbClr val="1F497D"/>
+        <a:srgbClr val="0E2841"/>
       </a:dk2>
       <a:lt2>
-        <a:srgbClr val="EEECE1"/>
+        <a:srgbClr val="E8E8E8"/>
       </a:lt2>
       <a:accent1>
-        <a:srgbClr val="4F81BD"/>
+        <a:srgbClr val="156082"/>
       </a:accent1>
       <a:accent2>
-        <a:srgbClr val="C0504D"/>
+        <a:srgbClr val="E97132"/>
       </a:accent2>
       <a:accent3>
-        <a:srgbClr val="9BBB59"/>
+        <a:srgbClr val="196B24"/>
       </a:accent3>
       <a:accent4>
-        <a:srgbClr val="8064A2"/>
+        <a:srgbClr val="0F9ED5"/>
       </a:accent4>
       <a:accent5>
-        <a:srgbClr val="4BACC6"/>
+        <a:srgbClr val="A02B93"/>
       </a:accent5>
       <a:accent6>
-        <a:srgbClr val="F79646"/>
+        <a:srgbClr val="4EA72E"/>
       </a:accent6>
       <a:hlink>
-        <a:srgbClr val="0000FF"/>
+        <a:srgbClr val="467886"/>
       </a:hlink>
       <a:folHlink>
-        <a:srgbClr val="800080"/>
+        <a:srgbClr val="96607D"/>
       </a:folHlink>
     </a:clrScheme>
     <a:fontScheme name="Office">
       <a:majorFont>
-        <a:latin typeface="Calibri"/>
+        <a:latin typeface="Aptos Display" panose="02110004020202020204"/>
         <a:ea typeface=""/>
         <a:cs typeface=""/>
-        <a:font script="Jpan" typeface="ＭＳ Ｐゴシック"/>
+        <a:font script="Jpan" typeface="游ゴシック Light"/>
         <a:font script="Hang" typeface="맑은 고딕"/>
-        <a:font script="Hans" typeface="宋体"/>
+        <a:font script="Hans" typeface="等线 Light"/>
         <a:font script="Hant" typeface="新細明體"/>
         <a:font script="Arab" typeface="Times New Roman"/>
         <a:font script="Hebr" typeface="Times New Roman"/>
@@ -12864,14 +13713,31 @@
         <a:font script="Viet" typeface="Times New Roman"/>
         <a:font script="Uigh" typeface="Microsoft Uighur"/>
         <a:font script="Geor" typeface="Sylfaen"/>
+        <a:font script="Armn" typeface="Arial"/>
+        <a:font script="Bugi" typeface="Leelawadee UI"/>
+        <a:font script="Bopo" typeface="Microsoft JhengHei"/>
+        <a:font script="Java" typeface="Javanese Text"/>
+        <a:font script="Lisu" typeface="Segoe UI"/>
+        <a:font script="Mymr" typeface="Myanmar Text"/>
+        <a:font script="Nkoo" typeface="Ebrima"/>
+        <a:font script="Olck" typeface="Nirmala UI"/>
+        <a:font script="Osma" typeface="Ebrima"/>
+        <a:font script="Phag" typeface="Phagspa"/>
+        <a:font script="Syrn" typeface="Estrangelo Edessa"/>
+        <a:font script="Syrj" typeface="Estrangelo Edessa"/>
+        <a:font script="Syre" typeface="Estrangelo Edessa"/>
+        <a:font script="Sora" typeface="Nirmala UI"/>
+        <a:font script="Tale" typeface="Microsoft Tai Le"/>
+        <a:font script="Talu" typeface="Microsoft New Tai Lue"/>
+        <a:font script="Tfng" typeface="Ebrima"/>
       </a:majorFont>
       <a:minorFont>
-        <a:latin typeface="Calibri"/>
+        <a:latin typeface="Aptos" panose="02110004020202020204"/>
         <a:ea typeface=""/>
         <a:cs typeface=""/>
-        <a:font script="Jpan" typeface="ＭＳ Ｐゴシック"/>
+        <a:font script="Jpan" typeface="游ゴシック"/>
         <a:font script="Hang" typeface="맑은 고딕"/>
-        <a:font script="Hans" typeface="宋体"/>
+        <a:font script="Hans" typeface="等线"/>
         <a:font script="Hant" typeface="新細明體"/>
         <a:font script="Arab" typeface="Arial"/>
         <a:font script="Hebr" typeface="Arial"/>
@@ -12899,6 +13765,23 @@
         <a:font script="Viet" typeface="Arial"/>
         <a:font script="Uigh" typeface="Microsoft Uighur"/>
         <a:font script="Geor" typeface="Sylfaen"/>
+        <a:font script="Armn" typeface="Arial"/>
+        <a:font script="Bugi" typeface="Leelawadee UI"/>
+        <a:font script="Bopo" typeface="Microsoft JhengHei"/>
+        <a:font script="Java" typeface="Javanese Text"/>
+        <a:font script="Lisu" typeface="Segoe UI"/>
+        <a:font script="Mymr" typeface="Myanmar Text"/>
+        <a:font script="Nkoo" typeface="Ebrima"/>
+        <a:font script="Olck" typeface="Nirmala UI"/>
+        <a:font script="Osma" typeface="Ebrima"/>
+        <a:font script="Phag" typeface="Phagspa"/>
+        <a:font script="Syrn" typeface="Estrangelo Edessa"/>
+        <a:font script="Syrj" typeface="Estrangelo Edessa"/>
+        <a:font script="Syre" typeface="Estrangelo Edessa"/>
+        <a:font script="Sora" typeface="Nirmala UI"/>
+        <a:font script="Tale" typeface="Microsoft Tai Le"/>
+        <a:font script="Talu" typeface="Microsoft New Tai Lue"/>
+        <a:font script="Tfng" typeface="Ebrima"/>
       </a:minorFont>
     </a:fontScheme>
     <a:fmtScheme name="Office">
@@ -12910,180 +13793,136 @@
           <a:gsLst>
             <a:gs pos="0">
               <a:schemeClr val="phClr">
-                <a:tint val="50000"/>
-                <a:satMod val="300000"/>
+                <a:lumMod val="110000"/>
+                <a:satMod val="105000"/>
+                <a:tint val="67000"/>
               </a:schemeClr>
             </a:gs>
-            <a:gs pos="35000">
+            <a:gs pos="50000">
               <a:schemeClr val="phClr">
-                <a:tint val="37000"/>
-                <a:satMod val="300000"/>
+                <a:lumMod val="105000"/>
+                <a:satMod val="103000"/>
+                <a:tint val="73000"/>
               </a:schemeClr>
             </a:gs>
             <a:gs pos="100000">
               <a:schemeClr val="phClr">
-                <a:tint val="15000"/>
-                <a:satMod val="350000"/>
+                <a:lumMod val="105000"/>
+                <a:satMod val="109000"/>
+                <a:tint val="81000"/>
               </a:schemeClr>
             </a:gs>
           </a:gsLst>
-          <a:lin ang="16200000" scaled="1"/>
+          <a:lin ang="5400000" scaled="0"/>
         </a:gradFill>
         <a:gradFill rotWithShape="1">
           <a:gsLst>
             <a:gs pos="0">
               <a:schemeClr val="phClr">
-                <a:tint val="100000"/>
+                <a:satMod val="103000"/>
+                <a:lumMod val="102000"/>
+                <a:tint val="94000"/>
+              </a:schemeClr>
+            </a:gs>
+            <a:gs pos="50000">
+              <a:schemeClr val="phClr">
+                <a:satMod val="110000"/>
+                <a:lumMod val="100000"/>
                 <a:shade val="100000"/>
-                <a:satMod val="130000"/>
               </a:schemeClr>
             </a:gs>
             <a:gs pos="100000">
               <a:schemeClr val="phClr">
-                <a:tint val="50000"/>
-                <a:shade val="100000"/>
-                <a:satMod val="350000"/>
+                <a:lumMod val="99000"/>
+                <a:satMod val="120000"/>
+                <a:shade val="78000"/>
               </a:schemeClr>
             </a:gs>
           </a:gsLst>
-          <a:lin ang="16200000" scaled="0"/>
+          <a:lin ang="5400000" scaled="0"/>
         </a:gradFill>
       </a:fillStyleLst>
       <a:lnStyleLst>
-        <a:ln w="9525" cap="flat" cmpd="sng" algn="ctr">
+        <a:ln w="12700" cap="flat" cmpd="sng" algn="ctr">
           <a:solidFill>
-            <a:schemeClr val="phClr">
-              <a:shade val="95000"/>
-              <a:satMod val="105000"/>
-            </a:schemeClr>
+            <a:schemeClr val="phClr"/>
           </a:solidFill>
           <a:prstDash val="solid"/>
+          <a:miter lim="800000"/>
+        </a:ln>
+        <a:ln w="19050" cap="flat" cmpd="sng" algn="ctr">
+          <a:solidFill>
+            <a:schemeClr val="phClr"/>
+          </a:solidFill>
+          <a:prstDash val="solid"/>
+          <a:miter lim="800000"/>
         </a:ln>
         <a:ln w="25400" cap="flat" cmpd="sng" algn="ctr">
           <a:solidFill>
             <a:schemeClr val="phClr"/>
           </a:solidFill>
           <a:prstDash val="solid"/>
-        </a:ln>
-        <a:ln w="38100" cap="flat" cmpd="sng" algn="ctr">
-          <a:solidFill>
-            <a:schemeClr val="phClr"/>
-          </a:solidFill>
-          <a:prstDash val="solid"/>
+          <a:miter lim="800000"/>
         </a:ln>
       </a:lnStyleLst>
       <a:effectStyleLst>
         <a:effectStyle>
+          <a:effectLst/>
+        </a:effectStyle>
+        <a:effectStyle>
+          <a:effectLst/>
+        </a:effectStyle>
+        <a:effectStyle>
           <a:effectLst>
-            <a:outerShdw blurRad="40000" dist="20000" dir="5400000" rotWithShape="0">
+            <a:outerShdw blurRad="57150" dist="19050" dir="5400000" algn="ctr" rotWithShape="0">
               <a:srgbClr val="000000">
-                <a:alpha val="38000"/>
+                <a:alpha val="63000"/>
               </a:srgbClr>
             </a:outerShdw>
           </a:effectLst>
-        </a:effectStyle>
-        <a:effectStyle>
-          <a:effectLst>
-            <a:outerShdw blurRad="40000" dist="23000" dir="5400000" rotWithShape="0">
-              <a:srgbClr val="000000">
-                <a:alpha val="35000"/>
-              </a:srgbClr>
-            </a:outerShdw>
-          </a:effectLst>
-        </a:effectStyle>
-        <a:effectStyle>
-          <a:effectLst>
-            <a:outerShdw blurRad="40000" dist="23000" dir="5400000" rotWithShape="0">
-              <a:srgbClr val="000000">
-                <a:alpha val="35000"/>
-              </a:srgbClr>
-            </a:outerShdw>
-          </a:effectLst>
-          <a:scene3d>
-            <a:camera prst="orthographicFront">
-              <a:rot lat="0" lon="0" rev="0"/>
-            </a:camera>
-            <a:lightRig rig="threePt" dir="t">
-              <a:rot lat="0" lon="0" rev="1200000"/>
-            </a:lightRig>
-          </a:scene3d>
-          <a:sp3d>
-            <a:bevelT w="63500" h="25400"/>
-          </a:sp3d>
         </a:effectStyle>
       </a:effectStyleLst>
       <a:bgFillStyleLst>
         <a:solidFill>
           <a:schemeClr val="phClr"/>
         </a:solidFill>
+        <a:solidFill>
+          <a:schemeClr val="phClr">
+            <a:tint val="95000"/>
+            <a:satMod val="170000"/>
+          </a:schemeClr>
+        </a:solidFill>
         <a:gradFill rotWithShape="1">
           <a:gsLst>
             <a:gs pos="0">
               <a:schemeClr val="phClr">
-                <a:tint val="40000"/>
-                <a:satMod val="350000"/>
+                <a:tint val="93000"/>
+                <a:satMod val="150000"/>
+                <a:shade val="98000"/>
+                <a:lumMod val="102000"/>
               </a:schemeClr>
             </a:gs>
-            <a:gs pos="40000">
+            <a:gs pos="50000">
               <a:schemeClr val="phClr">
-                <a:tint val="45000"/>
-                <a:shade val="99000"/>
-                <a:satMod val="350000"/>
+                <a:tint val="98000"/>
+                <a:satMod val="130000"/>
+                <a:shade val="90000"/>
+                <a:lumMod val="103000"/>
               </a:schemeClr>
             </a:gs>
             <a:gs pos="100000">
               <a:schemeClr val="phClr">
-                <a:shade val="20000"/>
-                <a:satMod val="255000"/>
+                <a:shade val="63000"/>
+                <a:satMod val="120000"/>
               </a:schemeClr>
             </a:gs>
           </a:gsLst>
-          <a:path path="circle">
-            <a:fillToRect l="50000" t="-80000" r="50000" b="180000"/>
-          </a:path>
-        </a:gradFill>
-        <a:gradFill rotWithShape="1">
-          <a:gsLst>
-            <a:gs pos="0">
-              <a:schemeClr val="phClr">
-                <a:tint val="80000"/>
-                <a:satMod val="300000"/>
-              </a:schemeClr>
-            </a:gs>
-            <a:gs pos="100000">
-              <a:schemeClr val="phClr">
-                <a:shade val="30000"/>
-                <a:satMod val="200000"/>
-              </a:schemeClr>
-            </a:gs>
-          </a:gsLst>
-          <a:path path="circle">
-            <a:fillToRect l="50000" t="50000" r="50000" b="50000"/>
-          </a:path>
+          <a:lin ang="5400000" scaled="0"/>
         </a:gradFill>
       </a:bgFillStyleLst>
     </a:fmtScheme>
   </a:themeElements>
   <a:objectDefaults>
-    <a:spDef>
-      <a:spPr/>
-      <a:bodyPr/>
-      <a:lstStyle/>
-      <a:style>
-        <a:lnRef idx="1">
-          <a:schemeClr val="accent1"/>
-        </a:lnRef>
-        <a:fillRef idx="3">
-          <a:schemeClr val="accent1"/>
-        </a:fillRef>
-        <a:effectRef idx="2">
-          <a:schemeClr val="accent1"/>
-        </a:effectRef>
-        <a:fontRef idx="minor">
-          <a:schemeClr val="lt1"/>
-        </a:fontRef>
-      </a:style>
-    </a:spDef>
     <a:lnDef>
       <a:spPr/>
       <a:bodyPr/>
@@ -13105,5 +13944,10 @@
     </a:lnDef>
   </a:objectDefaults>
   <a:extraClrSchemeLst/>
+  <a:extLst>
+    <a:ext uri="{05A4C25C-085E-4340-85A3-A5531E510DB2}">
+      <thm15:themeFamily xmlns:thm15="http://schemas.microsoft.com/office/thememl/2012/main" name="Office Theme" id="{2E142A2C-CD16-42D6-873A-C26D2A0506FA}" vid="{1BDDFF52-6CD6-40A5-AB3C-68EB2F1E4D0A}"/>
+    </a:ext>
+  </a:extLst>
 </a:theme>
 </file>
</xml_diff>